<commit_message>
chore(output): regenerate published results with label-based classification
188 requirement candidates (11 Critical review, 177 Unscored). The audit
log is a fresh 188-event chain; the previous chain remains in history.
</commit_message>
<xml_diff>
--- a/automotive_data_pipeline/output/published/BMW_board_deck.pptx
+++ b/automotive_data_pipeline/output/published/BMW_board_deck.pptx
@@ -3206,7 +3206,7 @@
               <a:rPr sz="1600">
                 <a:latin typeface="Aptos"/>
               </a:rPr>
-              <a:t>Critical review: G60 Sensor</a:t>
+              <a:t>Critical review: G70 Tire pressure control</a:t>
             </a:r>
           </a:p>
         </p:txBody>
@@ -3231,7 +3231,7 @@
               <a:rPr sz="1600">
                 <a:latin typeface="Aptos"/>
               </a:rPr>
-              <a:t>Improve sensor for G60 customers.</a:t>
+              <a:t>Improve 'Tire pressure control' for G70 customers.</a:t>
             </a:r>
           </a:p>
           <a:p>
@@ -3252,7 +3252,7 @@
               <a:rPr sz="1600">
                 <a:latin typeface="Aptos"/>
               </a:rPr>
-              <a:t>Sentiment: -34.6 | EHI: 57.2% | Priority: Unscored</a:t>
+              <a:t>Sentiment: -71.4 | EHI: 68.2% | Priority: Unscored</a:t>
             </a:r>
           </a:p>
           <a:p>
@@ -3273,34 +3273,34 @@
               <a:rPr sz="1600">
                 <a:latin typeface="Aptos"/>
               </a:rPr>
-              <a:t>• bmw-file://G60_feedback_hackathon.xlsx — Feedback_Explorer!row 232</a:t>
-            </a:r>
-          </a:p>
-          <a:p>
-            <a:pPr algn="l"/>
-            <a:r>
-              <a:rPr sz="1600">
-                <a:latin typeface="Aptos"/>
-              </a:rPr>
-              <a:t>• bmw-file://G60_feedback_hackathon.xlsx — Feedback_Explorer!row 995</a:t>
-            </a:r>
-          </a:p>
-          <a:p>
-            <a:pPr algn="l"/>
-            <a:r>
-              <a:rPr sz="1600">
-                <a:latin typeface="Aptos"/>
-              </a:rPr>
-              <a:t>• bmw-file://G60_feedback_hackathon.xlsx — Feedback_Explorer!row 1485</a:t>
-            </a:r>
-          </a:p>
-          <a:p>
-            <a:pPr algn="l"/>
-            <a:r>
-              <a:rPr sz="1600">
-                <a:latin typeface="Aptos"/>
-              </a:rPr>
-              <a:t>• bmw-file://G60_feedback_hackathon.xlsx — Feedback_Explorer!row 1658</a:t>
+              <a:t>• bmw-file://G70_feedback_hackathon.xlsx — Feedback_Explorer!row 786</a:t>
+            </a:r>
+          </a:p>
+          <a:p>
+            <a:pPr algn="l"/>
+            <a:r>
+              <a:rPr sz="1600">
+                <a:latin typeface="Aptos"/>
+              </a:rPr>
+              <a:t>• bmw-file://G70_feedback_hackathon.xlsx — Feedback_Explorer!row 813</a:t>
+            </a:r>
+          </a:p>
+          <a:p>
+            <a:pPr algn="l"/>
+            <a:r>
+              <a:rPr sz="1600">
+                <a:latin typeface="Aptos"/>
+              </a:rPr>
+              <a:t>• bmw-file://G70_feedback_hackathon.xlsx — Feedback_Explorer!row 1439</a:t>
+            </a:r>
+          </a:p>
+          <a:p>
+            <a:pPr algn="l"/>
+            <a:r>
+              <a:rPr sz="1600">
+                <a:latin typeface="Aptos"/>
+              </a:rPr>
+              <a:t>• bmw-file://G70_feedback_hackathon.xlsx — Feedback_Explorer!row 1957</a:t>
             </a:r>
           </a:p>
           <a:p>
@@ -3382,7 +3382,7 @@
               <a:rPr sz="1600">
                 <a:latin typeface="Aptos"/>
               </a:rPr>
-              <a:t>Critical review: G70 Collision</a:t>
+              <a:t>Critical review: G70 Cross Traffic Warning Rear with Brake Intervention</a:t>
             </a:r>
           </a:p>
         </p:txBody>
@@ -3407,28 +3407,28 @@
               <a:rPr sz="1600">
                 <a:latin typeface="Aptos"/>
               </a:rPr>
-              <a:t>Improve collision for G70 customers.</a:t>
-            </a:r>
-          </a:p>
-          <a:p>
-            <a:pPr algn="l"/>
-          </a:p>
-          <a:p>
-            <a:pPr algn="l"/>
-            <a:r>
-              <a:rPr sz="1600">
-                <a:latin typeface="Aptos"/>
-              </a:rPr>
-              <a:t>Category: C04 | Region: Unknown</a:t>
-            </a:r>
-          </a:p>
-          <a:p>
-            <a:pPr algn="l"/>
-            <a:r>
-              <a:rPr sz="1600">
-                <a:latin typeface="Aptos"/>
-              </a:rPr>
-              <a:t>Sentiment: -33.2 | EHI: 56.5% | Priority: Unscored</a:t>
+              <a:t>Improve 'Cross Traffic Warning Rear with Brake Intervention' for G70 customers.</a:t>
+            </a:r>
+          </a:p>
+          <a:p>
+            <a:pPr algn="l"/>
+          </a:p>
+          <a:p>
+            <a:pPr algn="l"/>
+            <a:r>
+              <a:rPr sz="1600">
+                <a:latin typeface="Aptos"/>
+              </a:rPr>
+              <a:t>Category: C04 | Region: US</a:t>
+            </a:r>
+          </a:p>
+          <a:p>
+            <a:pPr algn="l"/>
+            <a:r>
+              <a:rPr sz="1600">
+                <a:latin typeface="Aptos"/>
+              </a:rPr>
+              <a:t>Sentiment: -72.5 | EHI: 67.0% | Priority: Unscored</a:t>
             </a:r>
           </a:p>
           <a:p>
@@ -3449,34 +3449,34 @@
               <a:rPr sz="1600">
                 <a:latin typeface="Aptos"/>
               </a:rPr>
-              <a:t>• bmw-file://G70_feedback_hackathon.xlsx — Feedback_Explorer!row 294</a:t>
-            </a:r>
-          </a:p>
-          <a:p>
-            <a:pPr algn="l"/>
-            <a:r>
-              <a:rPr sz="1600">
-                <a:latin typeface="Aptos"/>
-              </a:rPr>
-              <a:t>• bmw-file://G70_feedback_hackathon.xlsx — Feedback_Explorer!row 528</a:t>
-            </a:r>
-          </a:p>
-          <a:p>
-            <a:pPr algn="l"/>
-            <a:r>
-              <a:rPr sz="1600">
-                <a:latin typeface="Aptos"/>
-              </a:rPr>
-              <a:t>• bmw-file://G70_feedback_hackathon.xlsx — Feedback_Explorer!row 2308</a:t>
-            </a:r>
-          </a:p>
-          <a:p>
-            <a:pPr algn="l"/>
-            <a:r>
-              <a:rPr sz="1600">
-                <a:latin typeface="Aptos"/>
-              </a:rPr>
-              <a:t>• bmw-file://G70_feedback_hackathon.xlsx — Feedback_Explorer!row 2309</a:t>
+              <a:t>• bmw-file://G70_feedback_hackathon.xlsx — Feedback_Explorer!row 383</a:t>
+            </a:r>
+          </a:p>
+          <a:p>
+            <a:pPr algn="l"/>
+            <a:r>
+              <a:rPr sz="1600">
+                <a:latin typeface="Aptos"/>
+              </a:rPr>
+              <a:t>• bmw-file://G70_feedback_hackathon.xlsx — Feedback_Explorer!row 885</a:t>
+            </a:r>
+          </a:p>
+          <a:p>
+            <a:pPr algn="l"/>
+            <a:r>
+              <a:rPr sz="1600">
+                <a:latin typeface="Aptos"/>
+              </a:rPr>
+              <a:t>• bmw-file://G70_feedback_hackathon.xlsx — Feedback_Explorer!row 955</a:t>
+            </a:r>
+          </a:p>
+          <a:p>
+            <a:pPr algn="l"/>
+            <a:r>
+              <a:rPr sz="1600">
+                <a:latin typeface="Aptos"/>
+              </a:rPr>
+              <a:t>• bmw-file://G70_feedback_hackathon.xlsx — Feedback_Explorer!row 2982</a:t>
             </a:r>
           </a:p>
           <a:p>
@@ -3558,7 +3558,7 @@
               <a:rPr sz="1600">
                 <a:latin typeface="Aptos"/>
               </a:rPr>
-              <a:t>Critical review: G60 Brake</a:t>
+              <a:t>Critical review: G70 Airbags</a:t>
             </a:r>
           </a:p>
         </p:txBody>
@@ -3583,7 +3583,7 @@
               <a:rPr sz="1600">
                 <a:latin typeface="Aptos"/>
               </a:rPr>
-              <a:t>Improve brake for G60 customers.</a:t>
+              <a:t>Improve 'Airbags' for G70 customers.</a:t>
             </a:r>
           </a:p>
           <a:p>
@@ -3604,7 +3604,7 @@
               <a:rPr sz="1600">
                 <a:latin typeface="Aptos"/>
               </a:rPr>
-              <a:t>Sentiment: -29.1 | EHI: 72.0% | Priority: Unscored</a:t>
+              <a:t>Sentiment: -73.0 | EHI: 65.6% | Priority: Unscored</a:t>
             </a:r>
           </a:p>
           <a:p>
@@ -3625,34 +3625,34 @@
               <a:rPr sz="1600">
                 <a:latin typeface="Aptos"/>
               </a:rPr>
-              <a:t>• bmw-file://G60_feedback_hackathon.xlsx — Feedback_Explorer!row 4</a:t>
-            </a:r>
-          </a:p>
-          <a:p>
-            <a:pPr algn="l"/>
-            <a:r>
-              <a:rPr sz="1600">
-                <a:latin typeface="Aptos"/>
-              </a:rPr>
-              <a:t>• bmw-file://G60_feedback_hackathon.xlsx — Feedback_Explorer!row 6</a:t>
-            </a:r>
-          </a:p>
-          <a:p>
-            <a:pPr algn="l"/>
-            <a:r>
-              <a:rPr sz="1600">
-                <a:latin typeface="Aptos"/>
-              </a:rPr>
-              <a:t>• bmw-file://G60_feedback_hackathon.xlsx — Feedback_Explorer!row 14</a:t>
-            </a:r>
-          </a:p>
-          <a:p>
-            <a:pPr algn="l"/>
-            <a:r>
-              <a:rPr sz="1600">
-                <a:latin typeface="Aptos"/>
-              </a:rPr>
-              <a:t>• bmw-file://G60_feedback_hackathon.xlsx — Feedback_Explorer!row 47</a:t>
+              <a:t>• bmw-file://G70_feedback_hackathon.xlsx — Feedback_Explorer!row 596</a:t>
+            </a:r>
+          </a:p>
+          <a:p>
+            <a:pPr algn="l"/>
+            <a:r>
+              <a:rPr sz="1600">
+                <a:latin typeface="Aptos"/>
+              </a:rPr>
+              <a:t>• bmw-file://G70_feedback_hackathon.xlsx — Feedback_Explorer!row 1618</a:t>
+            </a:r>
+          </a:p>
+          <a:p>
+            <a:pPr algn="l"/>
+            <a:r>
+              <a:rPr sz="1600">
+                <a:latin typeface="Aptos"/>
+              </a:rPr>
+              <a:t>• bmw-file://G70_feedback_hackathon.xlsx — Feedback_Explorer!row 2925</a:t>
+            </a:r>
+          </a:p>
+          <a:p>
+            <a:pPr algn="l"/>
+            <a:r>
+              <a:rPr sz="1600">
+                <a:latin typeface="Aptos"/>
+              </a:rPr>
+              <a:t>• bmw-file://G70_feedback_hackathon.xlsx — Feedback_Explorer!row 3346</a:t>
             </a:r>
           </a:p>
           <a:p>
@@ -3734,7 +3734,7 @@
               <a:rPr sz="1600">
                 <a:latin typeface="Aptos"/>
               </a:rPr>
-              <a:t>Critical review: G70 Brake</a:t>
+              <a:t>Critical review: G60 Emergency Stop Assistant</a:t>
             </a:r>
           </a:p>
         </p:txBody>
@@ -3759,28 +3759,28 @@
               <a:rPr sz="1600">
                 <a:latin typeface="Aptos"/>
               </a:rPr>
-              <a:t>Improve brake for G70 customers.</a:t>
-            </a:r>
-          </a:p>
-          <a:p>
-            <a:pPr algn="l"/>
-          </a:p>
-          <a:p>
-            <a:pPr algn="l"/>
-            <a:r>
-              <a:rPr sz="1600">
-                <a:latin typeface="Aptos"/>
-              </a:rPr>
-              <a:t>Category: C04 | Region: Unknown</a:t>
-            </a:r>
-          </a:p>
-          <a:p>
-            <a:pPr algn="l"/>
-            <a:r>
-              <a:rPr sz="1600">
-                <a:latin typeface="Aptos"/>
-              </a:rPr>
-              <a:t>Sentiment: -28.9 | EHI: 63.1% | Priority: Unscored</a:t>
+              <a:t>Improve 'Emergency Stop Assistant' for G60 customers.</a:t>
+            </a:r>
+          </a:p>
+          <a:p>
+            <a:pPr algn="l"/>
+          </a:p>
+          <a:p>
+            <a:pPr algn="l"/>
+            <a:r>
+              <a:rPr sz="1600">
+                <a:latin typeface="Aptos"/>
+              </a:rPr>
+              <a:t>Category: C04 | Region: US</a:t>
+            </a:r>
+          </a:p>
+          <a:p>
+            <a:pPr algn="l"/>
+            <a:r>
+              <a:rPr sz="1600">
+                <a:latin typeface="Aptos"/>
+              </a:rPr>
+              <a:t>Sentiment: -80.0 | EHI: 62.0% | Priority: Unscored</a:t>
             </a:r>
           </a:p>
           <a:p>
@@ -3801,34 +3801,25 @@
               <a:rPr sz="1600">
                 <a:latin typeface="Aptos"/>
               </a:rPr>
-              <a:t>• bmw-file://G70_feedback_hackathon.xlsx — Feedback_Explorer!row 73</a:t>
-            </a:r>
-          </a:p>
-          <a:p>
-            <a:pPr algn="l"/>
-            <a:r>
-              <a:rPr sz="1600">
-                <a:latin typeface="Aptos"/>
-              </a:rPr>
-              <a:t>• bmw-file://G70_feedback_hackathon.xlsx — Feedback_Explorer!row 225</a:t>
-            </a:r>
-          </a:p>
-          <a:p>
-            <a:pPr algn="l"/>
-            <a:r>
-              <a:rPr sz="1600">
-                <a:latin typeface="Aptos"/>
-              </a:rPr>
-              <a:t>• bmw-file://G70_feedback_hackathon.xlsx — Feedback_Explorer!row 239</a:t>
-            </a:r>
-          </a:p>
-          <a:p>
-            <a:pPr algn="l"/>
-            <a:r>
-              <a:rPr sz="1600">
-                <a:latin typeface="Aptos"/>
-              </a:rPr>
-              <a:t>• bmw-file://G70_feedback_hackathon.xlsx — Feedback_Explorer!row 383</a:t>
+              <a:t>• bmw-file://G60_feedback_hackathon.xlsx — Feedback_Explorer!row 1129</a:t>
+            </a:r>
+          </a:p>
+          <a:p>
+            <a:pPr algn="l"/>
+            <a:r>
+              <a:rPr sz="1600">
+                <a:latin typeface="Aptos"/>
+              </a:rPr>
+              <a:t>• bmw-file://G60_feedback_hackathon.xlsx — Feedback_Explorer!row 1736</a:t>
+            </a:r>
+          </a:p>
+          <a:p>
+            <a:pPr algn="l"/>
+            <a:r>
+              <a:rPr sz="1600">
+                <a:latin typeface="Aptos"/>
+              </a:rPr>
+              <a:t>• bmw-file://G60_feedback_hackathon.xlsx — Feedback_Explorer!row 4334</a:t>
             </a:r>
           </a:p>
           <a:p>
@@ -3910,7 +3901,7 @@
               <a:rPr sz="1600">
                 <a:latin typeface="Aptos"/>
               </a:rPr>
-              <a:t>Critical review: G60 Collision</a:t>
+              <a:t>Unscored: F70 Touch screen, operation</a:t>
             </a:r>
           </a:p>
         </p:txBody>
@@ -3935,28 +3926,28 @@
               <a:rPr sz="1600">
                 <a:latin typeface="Aptos"/>
               </a:rPr>
-              <a:t>Improve collision for G60 customers.</a:t>
-            </a:r>
-          </a:p>
-          <a:p>
-            <a:pPr algn="l"/>
-          </a:p>
-          <a:p>
-            <a:pPr algn="l"/>
-            <a:r>
-              <a:rPr sz="1600">
-                <a:latin typeface="Aptos"/>
-              </a:rPr>
-              <a:t>Category: C04 | Region: US</a:t>
-            </a:r>
-          </a:p>
-          <a:p>
-            <a:pPr algn="l"/>
-            <a:r>
-              <a:rPr sz="1600">
-                <a:latin typeface="Aptos"/>
-              </a:rPr>
-              <a:t>Sentiment: -16.6 | EHI: 57.2% | Priority: Unscored</a:t>
+              <a:t>Improve 'Touch screen, operation' for F70 customers.</a:t>
+            </a:r>
+          </a:p>
+          <a:p>
+            <a:pPr algn="l"/>
+          </a:p>
+          <a:p>
+            <a:pPr algn="l"/>
+            <a:r>
+              <a:rPr sz="1600">
+                <a:latin typeface="Aptos"/>
+              </a:rPr>
+              <a:t>Category: C07 | Region: All markets</a:t>
+            </a:r>
+          </a:p>
+          <a:p>
+            <a:pPr algn="l"/>
+            <a:r>
+              <a:rPr sz="1600">
+                <a:latin typeface="Aptos"/>
+              </a:rPr>
+              <a:t>Sentiment: -47.4 | EHI: 93.4% | Priority: Unscored</a:t>
             </a:r>
           </a:p>
           <a:p>
@@ -3977,34 +3968,34 @@
               <a:rPr sz="1600">
                 <a:latin typeface="Aptos"/>
               </a:rPr>
-              <a:t>• bmw-file://G60_feedback_hackathon.xlsx — Feedback_Explorer!row 183</a:t>
-            </a:r>
-          </a:p>
-          <a:p>
-            <a:pPr algn="l"/>
-            <a:r>
-              <a:rPr sz="1600">
-                <a:latin typeface="Aptos"/>
-              </a:rPr>
-              <a:t>• bmw-file://G60_feedback_hackathon.xlsx — Feedback_Explorer!row 715</a:t>
-            </a:r>
-          </a:p>
-          <a:p>
-            <a:pPr algn="l"/>
-            <a:r>
-              <a:rPr sz="1600">
-                <a:latin typeface="Aptos"/>
-              </a:rPr>
-              <a:t>• bmw-file://G60_feedback_hackathon.xlsx — Feedback_Explorer!row 716</a:t>
-            </a:r>
-          </a:p>
-          <a:p>
-            <a:pPr algn="l"/>
-            <a:r>
-              <a:rPr sz="1600">
-                <a:latin typeface="Aptos"/>
-              </a:rPr>
-              <a:t>• bmw-file://G60_feedback_hackathon.xlsx — Feedback_Explorer!row 717</a:t>
+              <a:t>• bmw-file://F70_feedback_hackathon.xlsx — Feedback_Explorer!row 23</a:t>
+            </a:r>
+          </a:p>
+          <a:p>
+            <a:pPr algn="l"/>
+            <a:r>
+              <a:rPr sz="1600">
+                <a:latin typeface="Aptos"/>
+              </a:rPr>
+              <a:t>• bmw-file://F70_feedback_hackathon.xlsx — Feedback_Explorer!row 24</a:t>
+            </a:r>
+          </a:p>
+          <a:p>
+            <a:pPr algn="l"/>
+            <a:r>
+              <a:rPr sz="1600">
+                <a:latin typeface="Aptos"/>
+              </a:rPr>
+              <a:t>• bmw-file://F70_feedback_hackathon.xlsx — Feedback_Explorer!row 25</a:t>
+            </a:r>
+          </a:p>
+          <a:p>
+            <a:pPr algn="l"/>
+            <a:r>
+              <a:rPr sz="1600">
+                <a:latin typeface="Aptos"/>
+              </a:rPr>
+              <a:t>• bmw-file://F70_feedback_hackathon.xlsx — Feedback_Explorer!row 26</a:t>
             </a:r>
           </a:p>
           <a:p>
@@ -4086,7 +4077,7 @@
               <a:rPr sz="1600">
                 <a:latin typeface="Aptos"/>
               </a:rPr>
-              <a:t>Critical review: G60 Blind Spot</a:t>
+              <a:t>Unscored: F70 Drivetrain</a:t>
             </a:r>
           </a:p>
         </p:txBody>
@@ -4111,28 +4102,28 @@
               <a:rPr sz="1600">
                 <a:latin typeface="Aptos"/>
               </a:rPr>
-              <a:t>Improve blind spot for G60 customers.</a:t>
-            </a:r>
-          </a:p>
-          <a:p>
-            <a:pPr algn="l"/>
-          </a:p>
-          <a:p>
-            <a:pPr algn="l"/>
-            <a:r>
-              <a:rPr sz="1600">
-                <a:latin typeface="Aptos"/>
-              </a:rPr>
-              <a:t>Category: C04 | Region: US</a:t>
-            </a:r>
-          </a:p>
-          <a:p>
-            <a:pPr algn="l"/>
-            <a:r>
-              <a:rPr sz="1600">
-                <a:latin typeface="Aptos"/>
-              </a:rPr>
-              <a:t>Sentiment: -13.7 | EHI: 57.3% | Priority: Unscored</a:t>
+              <a:t>Preserve 'Drivetrain' for F70 customers.</a:t>
+            </a:r>
+          </a:p>
+          <a:p>
+            <a:pPr algn="l"/>
+          </a:p>
+          <a:p>
+            <a:pPr algn="l"/>
+            <a:r>
+              <a:rPr sz="1600">
+                <a:latin typeface="Aptos"/>
+              </a:rPr>
+              <a:t>Category: C01 | Region: All markets</a:t>
+            </a:r>
+          </a:p>
+          <a:p>
+            <a:pPr algn="l"/>
+            <a:r>
+              <a:rPr sz="1600">
+                <a:latin typeface="Aptos"/>
+              </a:rPr>
+              <a:t>Sentiment: +46.1 | EHI: 92.8% | Priority: Unscored</a:t>
             </a:r>
           </a:p>
           <a:p>
@@ -4153,34 +4144,34 @@
               <a:rPr sz="1600">
                 <a:latin typeface="Aptos"/>
               </a:rPr>
-              <a:t>• bmw-file://G60_feedback_hackathon.xlsx — Feedback_Explorer!row 451</a:t>
-            </a:r>
-          </a:p>
-          <a:p>
-            <a:pPr algn="l"/>
-            <a:r>
-              <a:rPr sz="1600">
-                <a:latin typeface="Aptos"/>
-              </a:rPr>
-              <a:t>• bmw-file://G60_feedback_hackathon.xlsx — Feedback_Explorer!row 534</a:t>
-            </a:r>
-          </a:p>
-          <a:p>
-            <a:pPr algn="l"/>
-            <a:r>
-              <a:rPr sz="1600">
-                <a:latin typeface="Aptos"/>
-              </a:rPr>
-              <a:t>• bmw-file://G60_feedback_hackathon.xlsx — Feedback_Explorer!row 768</a:t>
-            </a:r>
-          </a:p>
-          <a:p>
-            <a:pPr algn="l"/>
-            <a:r>
-              <a:rPr sz="1600">
-                <a:latin typeface="Aptos"/>
-              </a:rPr>
-              <a:t>• bmw-file://G60_feedback_hackathon.xlsx — Feedback_Explorer!row 769</a:t>
+              <a:t>• bmw-file://F70_feedback_hackathon.xlsx — Feedback_Explorer!row 18</a:t>
+            </a:r>
+          </a:p>
+          <a:p>
+            <a:pPr algn="l"/>
+            <a:r>
+              <a:rPr sz="1600">
+                <a:latin typeface="Aptos"/>
+              </a:rPr>
+              <a:t>• bmw-file://F70_feedback_hackathon.xlsx — Feedback_Explorer!row 19</a:t>
+            </a:r>
+          </a:p>
+          <a:p>
+            <a:pPr algn="l"/>
+            <a:r>
+              <a:rPr sz="1600">
+                <a:latin typeface="Aptos"/>
+              </a:rPr>
+              <a:t>• bmw-file://F70_feedback_hackathon.xlsx — Feedback_Explorer!row 20</a:t>
+            </a:r>
+          </a:p>
+          <a:p>
+            <a:pPr algn="l"/>
+            <a:r>
+              <a:rPr sz="1600">
+                <a:latin typeface="Aptos"/>
+              </a:rPr>
+              <a:t>• bmw-file://F70_feedback_hackathon.xlsx — Feedback_Explorer!row 21</a:t>
             </a:r>
           </a:p>
           <a:p>
@@ -4262,7 +4253,7 @@
               <a:rPr sz="1600">
                 <a:latin typeface="Aptos"/>
               </a:rPr>
-              <a:t>Critical review: F70 Brake</a:t>
+              <a:t>Unscored: F70 ConnectedDrive and Infotainment, overall technology</a:t>
             </a:r>
           </a:p>
         </p:txBody>
@@ -4287,28 +4278,28 @@
               <a:rPr sz="1600">
                 <a:latin typeface="Aptos"/>
               </a:rPr>
-              <a:t>Preserve brake for F70 customers.</a:t>
-            </a:r>
-          </a:p>
-          <a:p>
-            <a:pPr algn="l"/>
-          </a:p>
-          <a:p>
-            <a:pPr algn="l"/>
-            <a:r>
-              <a:rPr sz="1600">
-                <a:latin typeface="Aptos"/>
-              </a:rPr>
-              <a:t>Category: C04 | Region: EU</a:t>
-            </a:r>
-          </a:p>
-          <a:p>
-            <a:pPr algn="l"/>
-            <a:r>
-              <a:rPr sz="1600">
-                <a:latin typeface="Aptos"/>
-              </a:rPr>
-              <a:t>Sentiment: +41.2 | EHI: 35.8% | Priority: Unscored</a:t>
+              <a:t>Improve 'ConnectedDrive and Infotainment, overall technology' for F70 customers.</a:t>
+            </a:r>
+          </a:p>
+          <a:p>
+            <a:pPr algn="l"/>
+          </a:p>
+          <a:p>
+            <a:pPr algn="l"/>
+            <a:r>
+              <a:rPr sz="1600">
+                <a:latin typeface="Aptos"/>
+              </a:rPr>
+              <a:t>Category: C07 | Region: All markets</a:t>
+            </a:r>
+          </a:p>
+          <a:p>
+            <a:pPr algn="l"/>
+            <a:r>
+              <a:rPr sz="1600">
+                <a:latin typeface="Aptos"/>
+              </a:rPr>
+              <a:t>Sentiment: -40.5 | EHI: 91.3% | Priority: Unscored</a:t>
             </a:r>
           </a:p>
           <a:p>
@@ -4329,34 +4320,34 @@
               <a:rPr sz="1600">
                 <a:latin typeface="Aptos"/>
               </a:rPr>
-              <a:t>• bmw-file://F70_feedback_hackathon.xlsx — Feedback_Explorer!row 725</a:t>
-            </a:r>
-          </a:p>
-          <a:p>
-            <a:pPr algn="l"/>
-            <a:r>
-              <a:rPr sz="1600">
-                <a:latin typeface="Aptos"/>
-              </a:rPr>
-              <a:t>• bmw-file://F70_feedback_hackathon.xlsx — Feedback_Explorer!row 899</a:t>
-            </a:r>
-          </a:p>
-          <a:p>
-            <a:pPr algn="l"/>
-            <a:r>
-              <a:rPr sz="1600">
-                <a:latin typeface="Aptos"/>
-              </a:rPr>
-              <a:t>• bmw-file://F70_feedback_hackathon.xlsx — Feedback_Explorer!row 900</a:t>
-            </a:r>
-          </a:p>
-          <a:p>
-            <a:pPr algn="l"/>
-            <a:r>
-              <a:rPr sz="1600">
-                <a:latin typeface="Aptos"/>
-              </a:rPr>
-              <a:t>• bmw-file://F70_feedback_hackathon.xlsx — Feedback_Explorer!row 1400</a:t>
+              <a:t>• bmw-file://F70_feedback_hackathon.xlsx — Feedback_Explorer!row 25</a:t>
+            </a:r>
+          </a:p>
+          <a:p>
+            <a:pPr algn="l"/>
+            <a:r>
+              <a:rPr sz="1600">
+                <a:latin typeface="Aptos"/>
+              </a:rPr>
+              <a:t>• bmw-file://F70_feedback_hackathon.xlsx — Feedback_Explorer!row 26</a:t>
+            </a:r>
+          </a:p>
+          <a:p>
+            <a:pPr algn="l"/>
+            <a:r>
+              <a:rPr sz="1600">
+                <a:latin typeface="Aptos"/>
+              </a:rPr>
+              <a:t>• bmw-file://F70_feedback_hackathon.xlsx — Feedback_Explorer!row 27</a:t>
+            </a:r>
+          </a:p>
+          <a:p>
+            <a:pPr algn="l"/>
+            <a:r>
+              <a:rPr sz="1600">
+                <a:latin typeface="Aptos"/>
+              </a:rPr>
+              <a:t>• bmw-file://F70_feedback_hackathon.xlsx — Feedback_Explorer!row 28</a:t>
             </a:r>
           </a:p>
           <a:p>
@@ -4438,7 +4429,7 @@
               <a:rPr sz="1600">
                 <a:latin typeface="Aptos"/>
               </a:rPr>
-              <a:t>Critical review: F70 Warning</a:t>
+              <a:t>Unscored: G60 Body equipment, overall technology</a:t>
             </a:r>
           </a:p>
         </p:txBody>
@@ -4463,28 +4454,28 @@
               <a:rPr sz="1600">
                 <a:latin typeface="Aptos"/>
               </a:rPr>
-              <a:t>Improve warning for F70 customers.</a:t>
-            </a:r>
-          </a:p>
-          <a:p>
-            <a:pPr algn="l"/>
-          </a:p>
-          <a:p>
-            <a:pPr algn="l"/>
-            <a:r>
-              <a:rPr sz="1600">
-                <a:latin typeface="Aptos"/>
-              </a:rPr>
-              <a:t>Category: C04 | Region: Unknown</a:t>
-            </a:r>
-          </a:p>
-          <a:p>
-            <a:pPr algn="l"/>
-            <a:r>
-              <a:rPr sz="1600">
-                <a:latin typeface="Aptos"/>
-              </a:rPr>
-              <a:t>Sentiment: +4.6 | EHI: 54.9% | Priority: Unscored</a:t>
+              <a:t>Review mixed feedback on 'Body equipment, overall technology' for G60 customers.</a:t>
+            </a:r>
+          </a:p>
+          <a:p>
+            <a:pPr algn="l"/>
+          </a:p>
+          <a:p>
+            <a:pPr algn="l"/>
+            <a:r>
+              <a:rPr sz="1600">
+                <a:latin typeface="Aptos"/>
+              </a:rPr>
+              <a:t>Category: C10 | Region: All markets</a:t>
+            </a:r>
+          </a:p>
+          <a:p>
+            <a:pPr algn="l"/>
+            <a:r>
+              <a:rPr sz="1600">
+                <a:latin typeface="Aptos"/>
+              </a:rPr>
+              <a:t>Sentiment: +21.6 | EHI: 94.5% | Priority: Unscored</a:t>
             </a:r>
           </a:p>
           <a:p>
@@ -4505,34 +4496,34 @@
               <a:rPr sz="1600">
                 <a:latin typeface="Aptos"/>
               </a:rPr>
-              <a:t>• bmw-file://F70_feedback_hackathon.xlsx — Feedback_Explorer!row 498</a:t>
-            </a:r>
-          </a:p>
-          <a:p>
-            <a:pPr algn="l"/>
-            <a:r>
-              <a:rPr sz="1600">
-                <a:latin typeface="Aptos"/>
-              </a:rPr>
-              <a:t>• bmw-file://F70_feedback_hackathon.xlsx — Feedback_Explorer!row 499</a:t>
-            </a:r>
-          </a:p>
-          <a:p>
-            <a:pPr algn="l"/>
-            <a:r>
-              <a:rPr sz="1600">
-                <a:latin typeface="Aptos"/>
-              </a:rPr>
-              <a:t>• bmw-file://F70_feedback_hackathon.xlsx — Feedback_Explorer!row 620</a:t>
-            </a:r>
-          </a:p>
-          <a:p>
-            <a:pPr algn="l"/>
-            <a:r>
-              <a:rPr sz="1600">
-                <a:latin typeface="Aptos"/>
-              </a:rPr>
-              <a:t>• bmw-file://F70_feedback_hackathon.xlsx — Feedback_Explorer!row 621</a:t>
+              <a:t>• bmw-file://G60_feedback_hackathon.xlsx — Feedback_Explorer!row 30</a:t>
+            </a:r>
+          </a:p>
+          <a:p>
+            <a:pPr algn="l"/>
+            <a:r>
+              <a:rPr sz="1600">
+                <a:latin typeface="Aptos"/>
+              </a:rPr>
+              <a:t>• bmw-file://G60_feedback_hackathon.xlsx — Feedback_Explorer!row 54</a:t>
+            </a:r>
+          </a:p>
+          <a:p>
+            <a:pPr algn="l"/>
+            <a:r>
+              <a:rPr sz="1600">
+                <a:latin typeface="Aptos"/>
+              </a:rPr>
+              <a:t>• bmw-file://G60_feedback_hackathon.xlsx — Feedback_Explorer!row 77</a:t>
+            </a:r>
+          </a:p>
+          <a:p>
+            <a:pPr algn="l"/>
+            <a:r>
+              <a:rPr sz="1600">
+                <a:latin typeface="Aptos"/>
+              </a:rPr>
+              <a:t>• bmw-file://G60_feedback_hackathon.xlsx — Feedback_Explorer!row 119</a:t>
             </a:r>
           </a:p>
           <a:p>
@@ -4614,7 +4605,7 @@
               <a:rPr sz="1600">
                 <a:latin typeface="Aptos"/>
               </a:rPr>
-              <a:t>Critical review: G60 Safety</a:t>
+              <a:t>Unscored: G60 Drivetrain</a:t>
             </a:r>
           </a:p>
         </p:txBody>
@@ -4639,28 +4630,28 @@
               <a:rPr sz="1600">
                 <a:latin typeface="Aptos"/>
               </a:rPr>
-              <a:t>Improve safety for G60 customers.</a:t>
-            </a:r>
-          </a:p>
-          <a:p>
-            <a:pPr algn="l"/>
-          </a:p>
-          <a:p>
-            <a:pPr algn="l"/>
-            <a:r>
-              <a:rPr sz="1600">
-                <a:latin typeface="Aptos"/>
-              </a:rPr>
-              <a:t>Category: C04 | Region: US</a:t>
-            </a:r>
-          </a:p>
-          <a:p>
-            <a:pPr algn="l"/>
-            <a:r>
-              <a:rPr sz="1600">
-                <a:latin typeface="Aptos"/>
-              </a:rPr>
-              <a:t>Sentiment: +14.2 | EHI: 55.3% | Priority: Unscored</a:t>
+              <a:t>Preserve 'Drivetrain' for G60 customers.</a:t>
+            </a:r>
+          </a:p>
+          <a:p>
+            <a:pPr algn="l"/>
+          </a:p>
+          <a:p>
+            <a:pPr algn="l"/>
+            <a:r>
+              <a:rPr sz="1600">
+                <a:latin typeface="Aptos"/>
+              </a:rPr>
+              <a:t>Category: C01 | Region: All markets</a:t>
+            </a:r>
+          </a:p>
+          <a:p>
+            <a:pPr algn="l"/>
+            <a:r>
+              <a:rPr sz="1600">
+                <a:latin typeface="Aptos"/>
+              </a:rPr>
+              <a:t>Sentiment: +52.9 | EHI: 93.8% | Priority: Unscored</a:t>
             </a:r>
           </a:p>
           <a:p>
@@ -4681,34 +4672,34 @@
               <a:rPr sz="1600">
                 <a:latin typeface="Aptos"/>
               </a:rPr>
-              <a:t>• bmw-file://G60_feedback_hackathon.xlsx — Feedback_Explorer!row 172</a:t>
-            </a:r>
-          </a:p>
-          <a:p>
-            <a:pPr algn="l"/>
-            <a:r>
-              <a:rPr sz="1600">
-                <a:latin typeface="Aptos"/>
-              </a:rPr>
-              <a:t>• bmw-file://G60_feedback_hackathon.xlsx — Feedback_Explorer!row 438</a:t>
-            </a:r>
-          </a:p>
-          <a:p>
-            <a:pPr algn="l"/>
-            <a:r>
-              <a:rPr sz="1600">
-                <a:latin typeface="Aptos"/>
-              </a:rPr>
-              <a:t>• bmw-file://G60_feedback_hackathon.xlsx — Feedback_Explorer!row 482</a:t>
-            </a:r>
-          </a:p>
-          <a:p>
-            <a:pPr algn="l"/>
-            <a:r>
-              <a:rPr sz="1600">
-                <a:latin typeface="Aptos"/>
-              </a:rPr>
-              <a:t>• bmw-file://G60_feedback_hackathon.xlsx — Feedback_Explorer!row 616</a:t>
+              <a:t>• bmw-file://G60_feedback_hackathon.xlsx — Feedback_Explorer!row 15</a:t>
+            </a:r>
+          </a:p>
+          <a:p>
+            <a:pPr algn="l"/>
+            <a:r>
+              <a:rPr sz="1600">
+                <a:latin typeface="Aptos"/>
+              </a:rPr>
+              <a:t>• bmw-file://G60_feedback_hackathon.xlsx — Feedback_Explorer!row 26</a:t>
+            </a:r>
+          </a:p>
+          <a:p>
+            <a:pPr algn="l"/>
+            <a:r>
+              <a:rPr sz="1600">
+                <a:latin typeface="Aptos"/>
+              </a:rPr>
+              <a:t>• bmw-file://G60_feedback_hackathon.xlsx — Feedback_Explorer!row 36</a:t>
+            </a:r>
+          </a:p>
+          <a:p>
+            <a:pPr algn="l"/>
+            <a:r>
+              <a:rPr sz="1600">
+                <a:latin typeface="Aptos"/>
+              </a:rPr>
+              <a:t>• bmw-file://G60_feedback_hackathon.xlsx — Feedback_Explorer!row 52</a:t>
             </a:r>
           </a:p>
           <a:p>
@@ -4790,7 +4781,7 @@
               <a:rPr sz="1600">
                 <a:latin typeface="Aptos"/>
               </a:rPr>
-              <a:t>Critical review: G70 Safety</a:t>
+              <a:t>Unscored: G70 Body equipment, overall technology</a:t>
             </a:r>
           </a:p>
         </p:txBody>
@@ -4815,28 +4806,28 @@
               <a:rPr sz="1600">
                 <a:latin typeface="Aptos"/>
               </a:rPr>
-              <a:t>Preserve safety for G70 customers.</a:t>
-            </a:r>
-          </a:p>
-          <a:p>
-            <a:pPr algn="l"/>
-          </a:p>
-          <a:p>
-            <a:pPr algn="l"/>
-            <a:r>
-              <a:rPr sz="1600">
-                <a:latin typeface="Aptos"/>
-              </a:rPr>
-              <a:t>Category: C04 | Region: Unknown</a:t>
-            </a:r>
-          </a:p>
-          <a:p>
-            <a:pPr algn="l"/>
-            <a:r>
-              <a:rPr sz="1600">
-                <a:latin typeface="Aptos"/>
-              </a:rPr>
-              <a:t>Sentiment: +8.5 | EHI: 65.7% | Priority: Unscored</a:t>
+              <a:t>Review mixed feedback on 'Body equipment, overall technology' for G70 customers.</a:t>
+            </a:r>
+          </a:p>
+          <a:p>
+            <a:pPr algn="l"/>
+          </a:p>
+          <a:p>
+            <a:pPr algn="l"/>
+            <a:r>
+              <a:rPr sz="1600">
+                <a:latin typeface="Aptos"/>
+              </a:rPr>
+              <a:t>Category: C10 | Region: All markets</a:t>
+            </a:r>
+          </a:p>
+          <a:p>
+            <a:pPr algn="l"/>
+            <a:r>
+              <a:rPr sz="1600">
+                <a:latin typeface="Aptos"/>
+              </a:rPr>
+              <a:t>Sentiment: +21.9 | EHI: 94.5% | Priority: Unscored</a:t>
             </a:r>
           </a:p>
           <a:p>
@@ -4857,34 +4848,34 @@
               <a:rPr sz="1600">
                 <a:latin typeface="Aptos"/>
               </a:rPr>
-              <a:t>• bmw-file://G70_feedback_hackathon.xlsx — Feedback_Explorer!row 94</a:t>
-            </a:r>
-          </a:p>
-          <a:p>
-            <a:pPr algn="l"/>
-            <a:r>
-              <a:rPr sz="1600">
-                <a:latin typeface="Aptos"/>
-              </a:rPr>
-              <a:t>• bmw-file://G70_feedback_hackathon.xlsx — Feedback_Explorer!row 144</a:t>
-            </a:r>
-          </a:p>
-          <a:p>
-            <a:pPr algn="l"/>
-            <a:r>
-              <a:rPr sz="1600">
-                <a:latin typeface="Aptos"/>
-              </a:rPr>
-              <a:t>• bmw-file://G70_feedback_hackathon.xlsx — Feedback_Explorer!row 161</a:t>
-            </a:r>
-          </a:p>
-          <a:p>
-            <a:pPr algn="l"/>
-            <a:r>
-              <a:rPr sz="1600">
-                <a:latin typeface="Aptos"/>
-              </a:rPr>
-              <a:t>• bmw-file://G70_feedback_hackathon.xlsx — Feedback_Explorer!row 162</a:t>
+              <a:t>• bmw-file://G70_feedback_hackathon.xlsx — Feedback_Explorer!row 26</a:t>
+            </a:r>
+          </a:p>
+          <a:p>
+            <a:pPr algn="l"/>
+            <a:r>
+              <a:rPr sz="1600">
+                <a:latin typeface="Aptos"/>
+              </a:rPr>
+              <a:t>• bmw-file://G70_feedback_hackathon.xlsx — Feedback_Explorer!row 33</a:t>
+            </a:r>
+          </a:p>
+          <a:p>
+            <a:pPr algn="l"/>
+            <a:r>
+              <a:rPr sz="1600">
+                <a:latin typeface="Aptos"/>
+              </a:rPr>
+              <a:t>• bmw-file://G70_feedback_hackathon.xlsx — Feedback_Explorer!row 93</a:t>
+            </a:r>
+          </a:p>
+          <a:p>
+            <a:pPr algn="l"/>
+            <a:r>
+              <a:rPr sz="1600">
+                <a:latin typeface="Aptos"/>
+              </a:rPr>
+              <a:t>• bmw-file://G70_feedback_hackathon.xlsx — Feedback_Explorer!row 157</a:t>
             </a:r>
           </a:p>
           <a:p>
@@ -5090,6 +5081,80 @@
                     <a:lstStyle/>
                     <a:p>
                       <a:r>
+                        <a:t>G60</a:t>
+                      </a:r>
+                    </a:p>
+                  </a:txBody>
+                  <a:tcPr/>
+                </a:tc>
+                <a:tc>
+                  <a:txBody>
+                    <a:bodyPr/>
+                    <a:lstStyle/>
+                    <a:p>
+                      <a:r>
+                        <a:t>C04</a:t>
+                      </a:r>
+                    </a:p>
+                  </a:txBody>
+                  <a:tcPr/>
+                </a:tc>
+                <a:tc>
+                  <a:txBody>
+                    <a:bodyPr/>
+                    <a:lstStyle/>
+                    <a:p>
+                      <a:r>
+                        <a:t>Improve 'Braking' for G60 customers.</a:t>
+                      </a:r>
+                    </a:p>
+                  </a:txBody>
+                  <a:tcPr/>
+                </a:tc>
+                <a:tc>
+                  <a:txBody>
+                    <a:bodyPr/>
+                    <a:lstStyle/>
+                    <a:p>
+                      <a:r>
+                        <a:t>-39</a:t>
+                      </a:r>
+                    </a:p>
+                  </a:txBody>
+                  <a:tcPr/>
+                </a:tc>
+                <a:tc>
+                  <a:txBody>
+                    <a:bodyPr/>
+                    <a:lstStyle/>
+                    <a:p>
+                      <a:r>
+                        <a:t>82%</a:t>
+                      </a:r>
+                    </a:p>
+                  </a:txBody>
+                  <a:tcPr/>
+                </a:tc>
+              </a:tr>
+              <a:tr h="457200">
+                <a:tc>
+                  <a:txBody>
+                    <a:bodyPr/>
+                    <a:lstStyle/>
+                    <a:p>
+                      <a:r>
+                        <a:t>Critical review</a:t>
+                      </a:r>
+                    </a:p>
+                  </a:txBody>
+                  <a:tcPr/>
+                </a:tc>
+                <a:tc>
+                  <a:txBody>
+                    <a:bodyPr/>
+                    <a:lstStyle/>
+                    <a:p>
+                      <a:r>
                         <a:t>G70</a:t>
                       </a:r>
                     </a:p>
@@ -5114,7 +5179,7 @@
                     <a:lstStyle/>
                     <a:p>
                       <a:r>
-                        <a:t>Improve emergency for G70 customers.</a:t>
+                        <a:t>Improve 'Braking' for G70 customers.</a:t>
                       </a:r>
                     </a:p>
                   </a:txBody>
@@ -5126,7 +5191,7 @@
                     <a:lstStyle/>
                     <a:p>
                       <a:r>
-                        <a:t>-79</a:t>
+                        <a:t>-39</a:t>
                       </a:r>
                     </a:p>
                   </a:txBody>
@@ -5138,7 +5203,7 @@
                     <a:lstStyle/>
                     <a:p>
                       <a:r>
-                        <a:t>58%</a:t>
+                        <a:t>81%</a:t>
                       </a:r>
                     </a:p>
                   </a:txBody>
@@ -5188,7 +5253,7 @@
                     <a:lstStyle/>
                     <a:p>
                       <a:r>
-                        <a:t>Improve collision for F70 customers.</a:t>
+                        <a:t>Improve 'Braking' for F70 customers.</a:t>
                       </a:r>
                     </a:p>
                   </a:txBody>
@@ -5200,7 +5265,7 @@
                     <a:lstStyle/>
                     <a:p>
                       <a:r>
-                        <a:t>-76</a:t>
+                        <a:t>-33</a:t>
                       </a:r>
                     </a:p>
                   </a:txBody>
@@ -5212,7 +5277,155 @@
                     <a:lstStyle/>
                     <a:p>
                       <a:r>
-                        <a:t>44%</a:t>
+                        <a:t>80%</a:t>
+                      </a:r>
+                    </a:p>
+                  </a:txBody>
+                  <a:tcPr/>
+                </a:tc>
+              </a:tr>
+              <a:tr h="457200">
+                <a:tc>
+                  <a:txBody>
+                    <a:bodyPr/>
+                    <a:lstStyle/>
+                    <a:p>
+                      <a:r>
+                        <a:t>Critical review</a:t>
+                      </a:r>
+                    </a:p>
+                  </a:txBody>
+                  <a:tcPr/>
+                </a:tc>
+                <a:tc>
+                  <a:txBody>
+                    <a:bodyPr/>
+                    <a:lstStyle/>
+                    <a:p>
+                      <a:r>
+                        <a:t>G60</a:t>
+                      </a:r>
+                    </a:p>
+                  </a:txBody>
+                  <a:tcPr/>
+                </a:tc>
+                <a:tc>
+                  <a:txBody>
+                    <a:bodyPr/>
+                    <a:lstStyle/>
+                    <a:p>
+                      <a:r>
+                        <a:t>C04</a:t>
+                      </a:r>
+                    </a:p>
+                  </a:txBody>
+                  <a:tcPr/>
+                </a:tc>
+                <a:tc>
+                  <a:txBody>
+                    <a:bodyPr/>
+                    <a:lstStyle/>
+                    <a:p>
+                      <a:r>
+                        <a:t>Improve 'Seat belts' for G60 customers.</a:t>
+                      </a:r>
+                    </a:p>
+                  </a:txBody>
+                  <a:tcPr/>
+                </a:tc>
+                <a:tc>
+                  <a:txBody>
+                    <a:bodyPr/>
+                    <a:lstStyle/>
+                    <a:p>
+                      <a:r>
+                        <a:t>-47</a:t>
+                      </a:r>
+                    </a:p>
+                  </a:txBody>
+                  <a:tcPr/>
+                </a:tc>
+                <a:tc>
+                  <a:txBody>
+                    <a:bodyPr/>
+                    <a:lstStyle/>
+                    <a:p>
+                      <a:r>
+                        <a:t>74%</a:t>
+                      </a:r>
+                    </a:p>
+                  </a:txBody>
+                  <a:tcPr/>
+                </a:tc>
+              </a:tr>
+              <a:tr h="457200">
+                <a:tc>
+                  <a:txBody>
+                    <a:bodyPr/>
+                    <a:lstStyle/>
+                    <a:p>
+                      <a:r>
+                        <a:t>Critical review</a:t>
+                      </a:r>
+                    </a:p>
+                  </a:txBody>
+                  <a:tcPr/>
+                </a:tc>
+                <a:tc>
+                  <a:txBody>
+                    <a:bodyPr/>
+                    <a:lstStyle/>
+                    <a:p>
+                      <a:r>
+                        <a:t>G60</a:t>
+                      </a:r>
+                    </a:p>
+                  </a:txBody>
+                  <a:tcPr/>
+                </a:tc>
+                <a:tc>
+                  <a:txBody>
+                    <a:bodyPr/>
+                    <a:lstStyle/>
+                    <a:p>
+                      <a:r>
+                        <a:t>C04</a:t>
+                      </a:r>
+                    </a:p>
+                  </a:txBody>
+                  <a:tcPr/>
+                </a:tc>
+                <a:tc>
+                  <a:txBody>
+                    <a:bodyPr/>
+                    <a:lstStyle/>
+                    <a:p>
+                      <a:r>
+                        <a:t>Improve 'Lane departure warning' for G60 customers.</a:t>
+                      </a:r>
+                    </a:p>
+                  </a:txBody>
+                  <a:tcPr/>
+                </a:tc>
+                <a:tc>
+                  <a:txBody>
+                    <a:bodyPr/>
+                    <a:lstStyle/>
+                    <a:p>
+                      <a:r>
+                        <a:t>-27</a:t>
+                      </a:r>
+                    </a:p>
+                  </a:txBody>
+                  <a:tcPr/>
+                </a:tc>
+                <a:tc>
+                  <a:txBody>
+                    <a:bodyPr/>
+                    <a:lstStyle/>
+                    <a:p>
+                      <a:r>
+                        <a:t>74%</a:t>
                       </a:r>
                     </a:p>
                   </a:txBody>
@@ -5262,7 +5475,7 @@
                     <a:lstStyle/>
                     <a:p>
                       <a:r>
-                        <a:t>Improve airbag for G70 customers.</a:t>
+                        <a:t>Improve 'Emergency request' for G70 customers.</a:t>
                       </a:r>
                     </a:p>
                   </a:txBody>
@@ -5286,7 +5499,7 @@
                     <a:lstStyle/>
                     <a:p>
                       <a:r>
-                        <a:t>50%</a:t>
+                        <a:t>69%</a:t>
                       </a:r>
                     </a:p>
                   </a:txBody>
@@ -5336,7 +5549,7 @@
                     <a:lstStyle/>
                     <a:p>
                       <a:r>
-                        <a:t>Improve emergency for G60 customers.</a:t>
+                        <a:t>Improve 'Emergency request' for G60 customers.</a:t>
                       </a:r>
                     </a:p>
                   </a:txBody>
@@ -5348,7 +5561,7 @@
                     <a:lstStyle/>
                     <a:p>
                       <a:r>
-                        <a:t>-58</a:t>
+                        <a:t>-53</a:t>
                       </a:r>
                     </a:p>
                   </a:txBody>
@@ -5360,7 +5573,7 @@
                     <a:lstStyle/>
                     <a:p>
                       <a:r>
-                        <a:t>58%</a:t>
+                        <a:t>69%</a:t>
                       </a:r>
                     </a:p>
                   </a:txBody>
@@ -5410,7 +5623,7 @@
                     <a:lstStyle/>
                     <a:p>
                       <a:r>
-                        <a:t>Improve sensor for G70 customers.</a:t>
+                        <a:t>Improve 'Tire pressure control' for G70 customers.</a:t>
                       </a:r>
                     </a:p>
                   </a:txBody>
@@ -5422,7 +5635,7 @@
                     <a:lstStyle/>
                     <a:p>
                       <a:r>
-                        <a:t>-51</a:t>
+                        <a:t>-71</a:t>
                       </a:r>
                     </a:p>
                   </a:txBody>
@@ -5434,81 +5647,7 @@
                     <a:lstStyle/>
                     <a:p>
                       <a:r>
-                        <a:t>57%</a:t>
-                      </a:r>
-                    </a:p>
-                  </a:txBody>
-                  <a:tcPr/>
-                </a:tc>
-              </a:tr>
-              <a:tr h="457200">
-                <a:tc>
-                  <a:txBody>
-                    <a:bodyPr/>
-                    <a:lstStyle/>
-                    <a:p>
-                      <a:r>
-                        <a:t>Critical review</a:t>
-                      </a:r>
-                    </a:p>
-                  </a:txBody>
-                  <a:tcPr/>
-                </a:tc>
-                <a:tc>
-                  <a:txBody>
-                    <a:bodyPr/>
-                    <a:lstStyle/>
-                    <a:p>
-                      <a:r>
-                        <a:t>G60</a:t>
-                      </a:r>
-                    </a:p>
-                  </a:txBody>
-                  <a:tcPr/>
-                </a:tc>
-                <a:tc>
-                  <a:txBody>
-                    <a:bodyPr/>
-                    <a:lstStyle/>
-                    <a:p>
-                      <a:r>
-                        <a:t>C04</a:t>
-                      </a:r>
-                    </a:p>
-                  </a:txBody>
-                  <a:tcPr/>
-                </a:tc>
-                <a:tc>
-                  <a:txBody>
-                    <a:bodyPr/>
-                    <a:lstStyle/>
-                    <a:p>
-                      <a:r>
-                        <a:t>Improve warning for G60 customers.</a:t>
-                      </a:r>
-                    </a:p>
-                  </a:txBody>
-                  <a:tcPr/>
-                </a:tc>
-                <a:tc>
-                  <a:txBody>
-                    <a:bodyPr/>
-                    <a:lstStyle/>
-                    <a:p>
-                      <a:r>
-                        <a:t>-50</a:t>
-                      </a:r>
-                    </a:p>
-                  </a:txBody>
-                  <a:tcPr/>
-                </a:tc>
-                <a:tc>
-                  <a:txBody>
-                    <a:bodyPr/>
-                    <a:lstStyle/>
-                    <a:p>
-                      <a:r>
-                        <a:t>64%</a:t>
+                        <a:t>68%</a:t>
                       </a:r>
                     </a:p>
                   </a:txBody>
@@ -5558,7 +5697,7 @@
                     <a:lstStyle/>
                     <a:p>
                       <a:r>
-                        <a:t>Improve warning for G70 customers.</a:t>
+                        <a:t>Improve 'Cross Traffic Warning Rear with Brake Intervention' for G70 customers.</a:t>
                       </a:r>
                     </a:p>
                   </a:txBody>
@@ -5570,7 +5709,7 @@
                     <a:lstStyle/>
                     <a:p>
                       <a:r>
-                        <a:t>-40</a:t>
+                        <a:t>-72</a:t>
                       </a:r>
                     </a:p>
                   </a:txBody>
@@ -5583,80 +5722,6 @@
                     <a:p>
                       <a:r>
                         <a:t>67%</a:t>
-                      </a:r>
-                    </a:p>
-                  </a:txBody>
-                  <a:tcPr/>
-                </a:tc>
-              </a:tr>
-              <a:tr h="457200">
-                <a:tc>
-                  <a:txBody>
-                    <a:bodyPr/>
-                    <a:lstStyle/>
-                    <a:p>
-                      <a:r>
-                        <a:t>Critical review</a:t>
-                      </a:r>
-                    </a:p>
-                  </a:txBody>
-                  <a:tcPr/>
-                </a:tc>
-                <a:tc>
-                  <a:txBody>
-                    <a:bodyPr/>
-                    <a:lstStyle/>
-                    <a:p>
-                      <a:r>
-                        <a:t>G60</a:t>
-                      </a:r>
-                    </a:p>
-                  </a:txBody>
-                  <a:tcPr/>
-                </a:tc>
-                <a:tc>
-                  <a:txBody>
-                    <a:bodyPr/>
-                    <a:lstStyle/>
-                    <a:p>
-                      <a:r>
-                        <a:t>C04</a:t>
-                      </a:r>
-                    </a:p>
-                  </a:txBody>
-                  <a:tcPr/>
-                </a:tc>
-                <a:tc>
-                  <a:txBody>
-                    <a:bodyPr/>
-                    <a:lstStyle/>
-                    <a:p>
-                      <a:r>
-                        <a:t>Improve sensor for G60 customers.</a:t>
-                      </a:r>
-                    </a:p>
-                  </a:txBody>
-                  <a:tcPr/>
-                </a:tc>
-                <a:tc>
-                  <a:txBody>
-                    <a:bodyPr/>
-                    <a:lstStyle/>
-                    <a:p>
-                      <a:r>
-                        <a:t>-35</a:t>
-                      </a:r>
-                    </a:p>
-                  </a:txBody>
-                  <a:tcPr/>
-                </a:tc>
-                <a:tc>
-                  <a:txBody>
-                    <a:bodyPr/>
-                    <a:lstStyle/>
-                    <a:p>
-                      <a:r>
-                        <a:t>57%</a:t>
                       </a:r>
                     </a:p>
                   </a:txBody>
@@ -5706,7 +5771,7 @@
                     <a:lstStyle/>
                     <a:p>
                       <a:r>
-                        <a:t>Improve collision for G70 customers.</a:t>
+                        <a:t>Improve 'Airbags' for G70 customers.</a:t>
                       </a:r>
                     </a:p>
                   </a:txBody>
@@ -5718,7 +5783,7 @@
                     <a:lstStyle/>
                     <a:p>
                       <a:r>
-                        <a:t>-33</a:t>
+                        <a:t>-73</a:t>
                       </a:r>
                     </a:p>
                   </a:txBody>
@@ -5730,81 +5795,7 @@
                     <a:lstStyle/>
                     <a:p>
                       <a:r>
-                        <a:t>56%</a:t>
-                      </a:r>
-                    </a:p>
-                  </a:txBody>
-                  <a:tcPr/>
-                </a:tc>
-              </a:tr>
-              <a:tr h="457200">
-                <a:tc>
-                  <a:txBody>
-                    <a:bodyPr/>
-                    <a:lstStyle/>
-                    <a:p>
-                      <a:r>
-                        <a:t>Critical review</a:t>
-                      </a:r>
-                    </a:p>
-                  </a:txBody>
-                  <a:tcPr/>
-                </a:tc>
-                <a:tc>
-                  <a:txBody>
-                    <a:bodyPr/>
-                    <a:lstStyle/>
-                    <a:p>
-                      <a:r>
-                        <a:t>G60</a:t>
-                      </a:r>
-                    </a:p>
-                  </a:txBody>
-                  <a:tcPr/>
-                </a:tc>
-                <a:tc>
-                  <a:txBody>
-                    <a:bodyPr/>
-                    <a:lstStyle/>
-                    <a:p>
-                      <a:r>
-                        <a:t>C04</a:t>
-                      </a:r>
-                    </a:p>
-                  </a:txBody>
-                  <a:tcPr/>
-                </a:tc>
-                <a:tc>
-                  <a:txBody>
-                    <a:bodyPr/>
-                    <a:lstStyle/>
-                    <a:p>
-                      <a:r>
-                        <a:t>Improve brake for G60 customers.</a:t>
-                      </a:r>
-                    </a:p>
-                  </a:txBody>
-                  <a:tcPr/>
-                </a:tc>
-                <a:tc>
-                  <a:txBody>
-                    <a:bodyPr/>
-                    <a:lstStyle/>
-                    <a:p>
-                      <a:r>
-                        <a:t>-29</a:t>
-                      </a:r>
-                    </a:p>
-                  </a:txBody>
-                  <a:tcPr/>
-                </a:tc>
-                <a:tc>
-                  <a:txBody>
-                    <a:bodyPr/>
-                    <a:lstStyle/>
-                    <a:p>
-                      <a:r>
-                        <a:t>72%</a:t>
+                        <a:t>66%</a:t>
                       </a:r>
                     </a:p>
                   </a:txBody>
@@ -5853,7 +5844,7 @@
               <a:rPr sz="1600">
                 <a:latin typeface="Aptos"/>
               </a:rPr>
-              <a:t>Unscored: G70 Handover</a:t>
+              <a:t>Unscored: F70 Owner's Manual</a:t>
             </a:r>
           </a:p>
         </p:txBody>
@@ -5878,28 +5869,28 @@
               <a:rPr sz="1600">
                 <a:latin typeface="Aptos"/>
               </a:rPr>
-              <a:t>Improve handover for G70 customers.</a:t>
-            </a:r>
-          </a:p>
-          <a:p>
-            <a:pPr algn="l"/>
-          </a:p>
-          <a:p>
-            <a:pPr algn="l"/>
-            <a:r>
-              <a:rPr sz="1600">
-                <a:latin typeface="Aptos"/>
-              </a:rPr>
-              <a:t>Category: C10 | Region: US</a:t>
-            </a:r>
-          </a:p>
-          <a:p>
-            <a:pPr algn="l"/>
-            <a:r>
-              <a:rPr sz="1600">
-                <a:latin typeface="Aptos"/>
-              </a:rPr>
-              <a:t>Sentiment: -80.0 | EHI: 40.3% | Priority: Unscored</a:t>
+              <a:t>Improve 'Owner's Manual' for F70 customers.</a:t>
+            </a:r>
+          </a:p>
+          <a:p>
+            <a:pPr algn="l"/>
+          </a:p>
+          <a:p>
+            <a:pPr algn="l"/>
+            <a:r>
+              <a:rPr sz="1600">
+                <a:latin typeface="Aptos"/>
+              </a:rPr>
+              <a:t>Category: C10 | Region: All markets</a:t>
+            </a:r>
+          </a:p>
+          <a:p>
+            <a:pPr algn="l"/>
+            <a:r>
+              <a:rPr sz="1600">
+                <a:latin typeface="Aptos"/>
+              </a:rPr>
+              <a:t>Sentiment: -52.8 | EHI: 87.1% | Priority: Unscored</a:t>
             </a:r>
           </a:p>
           <a:p>
@@ -5920,16 +5911,34 @@
               <a:rPr sz="1600">
                 <a:latin typeface="Aptos"/>
               </a:rPr>
-              <a:t>• bmw-file://G70_feedback_hackathon.xlsx — Feedback_Explorer!row 192</a:t>
-            </a:r>
-          </a:p>
-          <a:p>
-            <a:pPr algn="l"/>
-            <a:r>
-              <a:rPr sz="1600">
-                <a:latin typeface="Aptos"/>
-              </a:rPr>
-              <a:t>• bmw-file://G70_feedback_hackathon.xlsx — Feedback_Explorer!row 193</a:t>
+              <a:t>• bmw-file://F70_feedback_hackathon.xlsx — Feedback_Explorer!row 3</a:t>
+            </a:r>
+          </a:p>
+          <a:p>
+            <a:pPr algn="l"/>
+            <a:r>
+              <a:rPr sz="1600">
+                <a:latin typeface="Aptos"/>
+              </a:rPr>
+              <a:t>• bmw-file://F70_feedback_hackathon.xlsx — Feedback_Explorer!row 4</a:t>
+            </a:r>
+          </a:p>
+          <a:p>
+            <a:pPr algn="l"/>
+            <a:r>
+              <a:rPr sz="1600">
+                <a:latin typeface="Aptos"/>
+              </a:rPr>
+              <a:t>• bmw-file://F70_feedback_hackathon.xlsx — Feedback_Explorer!row 25</a:t>
+            </a:r>
+          </a:p>
+          <a:p>
+            <a:pPr algn="l"/>
+            <a:r>
+              <a:rPr sz="1600">
+                <a:latin typeface="Aptos"/>
+              </a:rPr>
+              <a:t>• bmw-file://F70_feedback_hackathon.xlsx — Feedback_Explorer!row 26</a:t>
             </a:r>
           </a:p>
           <a:p>
@@ -6011,7 +6020,7 @@
               <a:rPr sz="1600">
                 <a:latin typeface="Aptos"/>
               </a:rPr>
-              <a:t>Unscored: F70 Cost</a:t>
+              <a:t>Unscored: G60 Electric Range</a:t>
             </a:r>
           </a:p>
         </p:txBody>
@@ -6036,28 +6045,28 @@
               <a:rPr sz="1600">
                 <a:latin typeface="Aptos"/>
               </a:rPr>
-              <a:t>Improve cost for F70 customers.</a:t>
-            </a:r>
-          </a:p>
-          <a:p>
-            <a:pPr algn="l"/>
-          </a:p>
-          <a:p>
-            <a:pPr algn="l"/>
-            <a:r>
-              <a:rPr sz="1600">
-                <a:latin typeface="Aptos"/>
-              </a:rPr>
-              <a:t>Category: C03 | Region: EU</a:t>
-            </a:r>
-          </a:p>
-          <a:p>
-            <a:pPr algn="l"/>
-            <a:r>
-              <a:rPr sz="1600">
-                <a:latin typeface="Aptos"/>
-              </a:rPr>
-              <a:t>Sentiment: -76.7 | EHI: 46.6% | Priority: Unscored</a:t>
+              <a:t>Improve 'Electric Range' for G60 customers.</a:t>
+            </a:r>
+          </a:p>
+          <a:p>
+            <a:pPr algn="l"/>
+          </a:p>
+          <a:p>
+            <a:pPr algn="l"/>
+            <a:r>
+              <a:rPr sz="1600">
+                <a:latin typeface="Aptos"/>
+              </a:rPr>
+              <a:t>Category: C02 | Region: All markets</a:t>
+            </a:r>
+          </a:p>
+          <a:p>
+            <a:pPr algn="l"/>
+            <a:r>
+              <a:rPr sz="1600">
+                <a:latin typeface="Aptos"/>
+              </a:rPr>
+              <a:t>Sentiment: -12.9 | EHI: 88.5% | Priority: Unscored</a:t>
             </a:r>
           </a:p>
           <a:p>
@@ -6078,34 +6087,34 @@
               <a:rPr sz="1600">
                 <a:latin typeface="Aptos"/>
               </a:rPr>
-              <a:t>• bmw-file://F70_feedback_hackathon.xlsx — Feedback_Explorer!row 1692</a:t>
-            </a:r>
-          </a:p>
-          <a:p>
-            <a:pPr algn="l"/>
-            <a:r>
-              <a:rPr sz="1600">
-                <a:latin typeface="Aptos"/>
-              </a:rPr>
-              <a:t>• bmw-file://F70_feedback_hackathon.xlsx — Feedback_Explorer!row 2449</a:t>
-            </a:r>
-          </a:p>
-          <a:p>
-            <a:pPr algn="l"/>
-            <a:r>
-              <a:rPr sz="1600">
-                <a:latin typeface="Aptos"/>
-              </a:rPr>
-              <a:t>• bmw-file://F70_feedback_hackathon.xlsx — Feedback_Explorer!row 2450</a:t>
-            </a:r>
-          </a:p>
-          <a:p>
-            <a:pPr algn="l"/>
-            <a:r>
-              <a:rPr sz="1600">
-                <a:latin typeface="Aptos"/>
-              </a:rPr>
-              <a:t>• bmw-file://F70_feedback_hackathon.xlsx — Feedback_Explorer!row 2753</a:t>
+              <a:t>• bmw-file://G60_feedback_hackathon.xlsx — Feedback_Explorer!row 40</a:t>
+            </a:r>
+          </a:p>
+          <a:p>
+            <a:pPr algn="l"/>
+            <a:r>
+              <a:rPr sz="1600">
+                <a:latin typeface="Aptos"/>
+              </a:rPr>
+              <a:t>• bmw-file://G60_feedback_hackathon.xlsx — Feedback_Explorer!row 41</a:t>
+            </a:r>
+          </a:p>
+          <a:p>
+            <a:pPr algn="l"/>
+            <a:r>
+              <a:rPr sz="1600">
+                <a:latin typeface="Aptos"/>
+              </a:rPr>
+              <a:t>• bmw-file://G60_feedback_hackathon.xlsx — Feedback_Explorer!row 42</a:t>
+            </a:r>
+          </a:p>
+          <a:p>
+            <a:pPr algn="l"/>
+            <a:r>
+              <a:rPr sz="1600">
+                <a:latin typeface="Aptos"/>
+              </a:rPr>
+              <a:t>• bmw-file://G60_feedback_hackathon.xlsx — Feedback_Explorer!row 59</a:t>
             </a:r>
           </a:p>
           <a:p>
@@ -6187,7 +6196,7 @@
               <a:rPr sz="1600">
                 <a:latin typeface="Aptos"/>
               </a:rPr>
-              <a:t>Unscored: G60 Vibration</a:t>
+              <a:t>Unscored: G60 Seats</a:t>
             </a:r>
           </a:p>
         </p:txBody>
@@ -6212,28 +6221,28 @@
               <a:rPr sz="1600">
                 <a:latin typeface="Aptos"/>
               </a:rPr>
-              <a:t>Improve vibration for G60 customers.</a:t>
-            </a:r>
-          </a:p>
-          <a:p>
-            <a:pPr algn="l"/>
-          </a:p>
-          <a:p>
-            <a:pPr algn="l"/>
-            <a:r>
-              <a:rPr sz="1600">
-                <a:latin typeface="Aptos"/>
-              </a:rPr>
-              <a:t>Category: C05 | Region: US</a:t>
-            </a:r>
-          </a:p>
-          <a:p>
-            <a:pPr algn="l"/>
-            <a:r>
-              <a:rPr sz="1600">
-                <a:latin typeface="Aptos"/>
-              </a:rPr>
-              <a:t>Sentiment: -80.0 | EHI: 40.3% | Priority: Unscored</a:t>
+              <a:t>Improve 'Seats' for G60 customers.</a:t>
+            </a:r>
+          </a:p>
+          <a:p>
+            <a:pPr algn="l"/>
+          </a:p>
+          <a:p>
+            <a:pPr algn="l"/>
+            <a:r>
+              <a:rPr sz="1600">
+                <a:latin typeface="Aptos"/>
+              </a:rPr>
+              <a:t>Category: C05 | Region: All markets</a:t>
+            </a:r>
+          </a:p>
+          <a:p>
+            <a:pPr algn="l"/>
+            <a:r>
+              <a:rPr sz="1600">
+                <a:latin typeface="Aptos"/>
+              </a:rPr>
+              <a:t>Sentiment: -1.0 | EHI: 90.5% | Priority: Unscored</a:t>
             </a:r>
           </a:p>
           <a:p>
@@ -6254,7 +6263,34 @@
               <a:rPr sz="1600">
                 <a:latin typeface="Aptos"/>
               </a:rPr>
-              <a:t>• bmw-file://G60_feedback_hackathon.xlsx — Feedback_Explorer!row 423</a:t>
+              <a:t>• bmw-file://G60_feedback_hackathon.xlsx — Feedback_Explorer!row 37</a:t>
+            </a:r>
+          </a:p>
+          <a:p>
+            <a:pPr algn="l"/>
+            <a:r>
+              <a:rPr sz="1600">
+                <a:latin typeface="Aptos"/>
+              </a:rPr>
+              <a:t>• bmw-file://G60_feedback_hackathon.xlsx — Feedback_Explorer!row 38</a:t>
+            </a:r>
+          </a:p>
+          <a:p>
+            <a:pPr algn="l"/>
+            <a:r>
+              <a:rPr sz="1600">
+                <a:latin typeface="Aptos"/>
+              </a:rPr>
+              <a:t>• bmw-file://G60_feedback_hackathon.xlsx — Feedback_Explorer!row 39</a:t>
+            </a:r>
+          </a:p>
+          <a:p>
+            <a:pPr algn="l"/>
+            <a:r>
+              <a:rPr sz="1600">
+                <a:latin typeface="Aptos"/>
+              </a:rPr>
+              <a:t>• bmw-file://G60_feedback_hackathon.xlsx — Feedback_Explorer!row 131</a:t>
             </a:r>
           </a:p>
           <a:p>
@@ -6336,7 +6372,7 @@
               <a:rPr sz="1600">
                 <a:latin typeface="Aptos"/>
               </a:rPr>
-              <a:t>Critical review: G70 Emergency</a:t>
+              <a:t>Critical review: G60 Braking</a:t>
             </a:r>
           </a:p>
         </p:txBody>
@@ -6361,28 +6397,28 @@
               <a:rPr sz="1600">
                 <a:latin typeface="Aptos"/>
               </a:rPr>
-              <a:t>Improve emergency for G70 customers.</a:t>
-            </a:r>
-          </a:p>
-          <a:p>
-            <a:pPr algn="l"/>
-          </a:p>
-          <a:p>
-            <a:pPr algn="l"/>
-            <a:r>
-              <a:rPr sz="1600">
-                <a:latin typeface="Aptos"/>
-              </a:rPr>
-              <a:t>Category: C04 | Region: US</a:t>
-            </a:r>
-          </a:p>
-          <a:p>
-            <a:pPr algn="l"/>
-            <a:r>
-              <a:rPr sz="1600">
-                <a:latin typeface="Aptos"/>
-              </a:rPr>
-              <a:t>Sentiment: -78.6 | EHI: 58.5% | Priority: Unscored</a:t>
+              <a:t>Improve 'Braking' for G60 customers.</a:t>
+            </a:r>
+          </a:p>
+          <a:p>
+            <a:pPr algn="l"/>
+          </a:p>
+          <a:p>
+            <a:pPr algn="l"/>
+            <a:r>
+              <a:rPr sz="1600">
+                <a:latin typeface="Aptos"/>
+              </a:rPr>
+              <a:t>Category: C04 | Region: All markets</a:t>
+            </a:r>
+          </a:p>
+          <a:p>
+            <a:pPr algn="l"/>
+            <a:r>
+              <a:rPr sz="1600">
+                <a:latin typeface="Aptos"/>
+              </a:rPr>
+              <a:t>Sentiment: -38.8 | EHI: 82.2% | Priority: Unscored</a:t>
             </a:r>
           </a:p>
           <a:p>
@@ -6403,34 +6439,34 @@
               <a:rPr sz="1600">
                 <a:latin typeface="Aptos"/>
               </a:rPr>
-              <a:t>• bmw-file://G70_feedback_hackathon.xlsx — Feedback_Explorer!row 116</a:t>
-            </a:r>
-          </a:p>
-          <a:p>
-            <a:pPr algn="l"/>
-            <a:r>
-              <a:rPr sz="1600">
-                <a:latin typeface="Aptos"/>
-              </a:rPr>
-              <a:t>• bmw-file://G70_feedback_hackathon.xlsx — Feedback_Explorer!row 158</a:t>
-            </a:r>
-          </a:p>
-          <a:p>
-            <a:pPr algn="l"/>
-            <a:r>
-              <a:rPr sz="1600">
-                <a:latin typeface="Aptos"/>
-              </a:rPr>
-              <a:t>• bmw-file://G70_feedback_hackathon.xlsx — Feedback_Explorer!row 525</a:t>
-            </a:r>
-          </a:p>
-          <a:p>
-            <a:pPr algn="l"/>
-            <a:r>
-              <a:rPr sz="1600">
-                <a:latin typeface="Aptos"/>
-              </a:rPr>
-              <a:t>• bmw-file://G70_feedback_hackathon.xlsx — Feedback_Explorer!row 2513</a:t>
+              <a:t>• bmw-file://G60_feedback_hackathon.xlsx — Feedback_Explorer!row 297</a:t>
+            </a:r>
+          </a:p>
+          <a:p>
+            <a:pPr algn="l"/>
+            <a:r>
+              <a:rPr sz="1600">
+                <a:latin typeface="Aptos"/>
+              </a:rPr>
+              <a:t>• bmw-file://G60_feedback_hackathon.xlsx — Feedback_Explorer!row 298</a:t>
+            </a:r>
+          </a:p>
+          <a:p>
+            <a:pPr algn="l"/>
+            <a:r>
+              <a:rPr sz="1600">
+                <a:latin typeface="Aptos"/>
+              </a:rPr>
+              <a:t>• bmw-file://G60_feedback_hackathon.xlsx — Feedback_Explorer!row 299</a:t>
+            </a:r>
+          </a:p>
+          <a:p>
+            <a:pPr algn="l"/>
+            <a:r>
+              <a:rPr sz="1600">
+                <a:latin typeface="Aptos"/>
+              </a:rPr>
+              <a:t>• bmw-file://G60_feedback_hackathon.xlsx — Feedback_Explorer!row 300</a:t>
             </a:r>
           </a:p>
           <a:p>
@@ -6512,7 +6548,7 @@
               <a:rPr sz="1600">
                 <a:latin typeface="Aptos"/>
               </a:rPr>
-              <a:t>Critical review: F70 Collision</a:t>
+              <a:t>Critical review: G70 Braking</a:t>
             </a:r>
           </a:p>
         </p:txBody>
@@ -6537,28 +6573,28 @@
               <a:rPr sz="1600">
                 <a:latin typeface="Aptos"/>
               </a:rPr>
-              <a:t>Improve collision for F70 customers.</a:t>
-            </a:r>
-          </a:p>
-          <a:p>
-            <a:pPr algn="l"/>
-          </a:p>
-          <a:p>
-            <a:pPr algn="l"/>
-            <a:r>
-              <a:rPr sz="1600">
-                <a:latin typeface="Aptos"/>
-              </a:rPr>
-              <a:t>Category: C04 | Region: EU</a:t>
-            </a:r>
-          </a:p>
-          <a:p>
-            <a:pPr algn="l"/>
-            <a:r>
-              <a:rPr sz="1600">
-                <a:latin typeface="Aptos"/>
-              </a:rPr>
-              <a:t>Sentiment: -76.0 | EHI: 44.0% | Priority: Unscored</a:t>
+              <a:t>Improve 'Braking' for G70 customers.</a:t>
+            </a:r>
+          </a:p>
+          <a:p>
+            <a:pPr algn="l"/>
+          </a:p>
+          <a:p>
+            <a:pPr algn="l"/>
+            <a:r>
+              <a:rPr sz="1600">
+                <a:latin typeface="Aptos"/>
+              </a:rPr>
+              <a:t>Category: C04 | Region: All markets</a:t>
+            </a:r>
+          </a:p>
+          <a:p>
+            <a:pPr algn="l"/>
+            <a:r>
+              <a:rPr sz="1600">
+                <a:latin typeface="Aptos"/>
+              </a:rPr>
+              <a:t>Sentiment: -38.7 | EHI: 80.7% | Priority: Unscored</a:t>
             </a:r>
           </a:p>
           <a:p>
@@ -6579,34 +6615,34 @@
               <a:rPr sz="1600">
                 <a:latin typeface="Aptos"/>
               </a:rPr>
-              <a:t>• bmw-file://F70_feedback_hackathon.xlsx — Feedback_Explorer!row 2535</a:t>
-            </a:r>
-          </a:p>
-          <a:p>
-            <a:pPr algn="l"/>
-            <a:r>
-              <a:rPr sz="1600">
-                <a:latin typeface="Aptos"/>
-              </a:rPr>
-              <a:t>• bmw-file://F70_feedback_hackathon.xlsx — Feedback_Explorer!row 4002</a:t>
-            </a:r>
-          </a:p>
-          <a:p>
-            <a:pPr algn="l"/>
-            <a:r>
-              <a:rPr sz="1600">
-                <a:latin typeface="Aptos"/>
-              </a:rPr>
-              <a:t>• bmw-file://F70_feedback_hackathon.xlsx — Feedback_Explorer!row 4003</a:t>
-            </a:r>
-          </a:p>
-          <a:p>
-            <a:pPr algn="l"/>
-            <a:r>
-              <a:rPr sz="1600">
-                <a:latin typeface="Aptos"/>
-              </a:rPr>
-              <a:t>• bmw-file://F70_feedback_hackathon.xlsx — Feedback_Explorer!row 4004</a:t>
+              <a:t>• bmw-file://G70_feedback_hackathon.xlsx — Feedback_Explorer!row 514</a:t>
+            </a:r>
+          </a:p>
+          <a:p>
+            <a:pPr algn="l"/>
+            <a:r>
+              <a:rPr sz="1600">
+                <a:latin typeface="Aptos"/>
+              </a:rPr>
+              <a:t>• bmw-file://G70_feedback_hackathon.xlsx — Feedback_Explorer!row 515</a:t>
+            </a:r>
+          </a:p>
+          <a:p>
+            <a:pPr algn="l"/>
+            <a:r>
+              <a:rPr sz="1600">
+                <a:latin typeface="Aptos"/>
+              </a:rPr>
+              <a:t>• bmw-file://G70_feedback_hackathon.xlsx — Feedback_Explorer!row 516</a:t>
+            </a:r>
+          </a:p>
+          <a:p>
+            <a:pPr algn="l"/>
+            <a:r>
+              <a:rPr sz="1600">
+                <a:latin typeface="Aptos"/>
+              </a:rPr>
+              <a:t>• bmw-file://G70_feedback_hackathon.xlsx — Feedback_Explorer!row 1036</a:t>
             </a:r>
           </a:p>
           <a:p>
@@ -6688,7 +6724,7 @@
               <a:rPr sz="1600">
                 <a:latin typeface="Aptos"/>
               </a:rPr>
-              <a:t>Critical review: G70 Airbag</a:t>
+              <a:t>Critical review: F70 Braking</a:t>
             </a:r>
           </a:p>
         </p:txBody>
@@ -6713,28 +6749,28 @@
               <a:rPr sz="1600">
                 <a:latin typeface="Aptos"/>
               </a:rPr>
-              <a:t>Improve airbag for G70 customers.</a:t>
-            </a:r>
-          </a:p>
-          <a:p>
-            <a:pPr algn="l"/>
-          </a:p>
-          <a:p>
-            <a:pPr algn="l"/>
-            <a:r>
-              <a:rPr sz="1600">
-                <a:latin typeface="Aptos"/>
-              </a:rPr>
-              <a:t>Category: C04 | Region: US</a:t>
-            </a:r>
-          </a:p>
-          <a:p>
-            <a:pPr algn="l"/>
-            <a:r>
-              <a:rPr sz="1600">
-                <a:latin typeface="Aptos"/>
-              </a:rPr>
-              <a:t>Sentiment: -76.0 | EHI: 50.2% | Priority: Unscored</a:t>
+              <a:t>Improve 'Braking' for F70 customers.</a:t>
+            </a:r>
+          </a:p>
+          <a:p>
+            <a:pPr algn="l"/>
+          </a:p>
+          <a:p>
+            <a:pPr algn="l"/>
+            <a:r>
+              <a:rPr sz="1600">
+                <a:latin typeface="Aptos"/>
+              </a:rPr>
+              <a:t>Category: C04 | Region: All markets</a:t>
+            </a:r>
+          </a:p>
+          <a:p>
+            <a:pPr algn="l"/>
+            <a:r>
+              <a:rPr sz="1600">
+                <a:latin typeface="Aptos"/>
+              </a:rPr>
+              <a:t>Sentiment: -33.2 | EHI: 79.8% | Priority: Unscored</a:t>
             </a:r>
           </a:p>
           <a:p>
@@ -6755,34 +6791,34 @@
               <a:rPr sz="1600">
                 <a:latin typeface="Aptos"/>
               </a:rPr>
-              <a:t>• bmw-file://G70_feedback_hackathon.xlsx — Feedback_Explorer!row 596</a:t>
-            </a:r>
-          </a:p>
-          <a:p>
-            <a:pPr algn="l"/>
-            <a:r>
-              <a:rPr sz="1600">
-                <a:latin typeface="Aptos"/>
-              </a:rPr>
-              <a:t>• bmw-file://G70_feedback_hackathon.xlsx — Feedback_Explorer!row 1618</a:t>
-            </a:r>
-          </a:p>
-          <a:p>
-            <a:pPr algn="l"/>
-            <a:r>
-              <a:rPr sz="1600">
-                <a:latin typeface="Aptos"/>
-              </a:rPr>
-              <a:t>• bmw-file://G70_feedback_hackathon.xlsx — Feedback_Explorer!row 2925</a:t>
-            </a:r>
-          </a:p>
-          <a:p>
-            <a:pPr algn="l"/>
-            <a:r>
-              <a:rPr sz="1600">
-                <a:latin typeface="Aptos"/>
-              </a:rPr>
-              <a:t>• bmw-file://G70_feedback_hackathon.xlsx — Feedback_Explorer!row 3346</a:t>
+              <a:t>• bmw-file://F70_feedback_hackathon.xlsx — Feedback_Explorer!row 67</a:t>
+            </a:r>
+          </a:p>
+          <a:p>
+            <a:pPr algn="l"/>
+            <a:r>
+              <a:rPr sz="1600">
+                <a:latin typeface="Aptos"/>
+              </a:rPr>
+              <a:t>• bmw-file://F70_feedback_hackathon.xlsx — Feedback_Explorer!row 68</a:t>
+            </a:r>
+          </a:p>
+          <a:p>
+            <a:pPr algn="l"/>
+            <a:r>
+              <a:rPr sz="1600">
+                <a:latin typeface="Aptos"/>
+              </a:rPr>
+              <a:t>• bmw-file://F70_feedback_hackathon.xlsx — Feedback_Explorer!row 172</a:t>
+            </a:r>
+          </a:p>
+          <a:p>
+            <a:pPr algn="l"/>
+            <a:r>
+              <a:rPr sz="1600">
+                <a:latin typeface="Aptos"/>
+              </a:rPr>
+              <a:t>• bmw-file://F70_feedback_hackathon.xlsx — Feedback_Explorer!row 173</a:t>
             </a:r>
           </a:p>
           <a:p>
@@ -6864,7 +6900,7 @@
               <a:rPr sz="1600">
                 <a:latin typeface="Aptos"/>
               </a:rPr>
-              <a:t>Critical review: G60 Emergency</a:t>
+              <a:t>Critical review: G60 Seat belts</a:t>
             </a:r>
           </a:p>
         </p:txBody>
@@ -6889,28 +6925,28 @@
               <a:rPr sz="1600">
                 <a:latin typeface="Aptos"/>
               </a:rPr>
-              <a:t>Improve emergency for G60 customers.</a:t>
-            </a:r>
-          </a:p>
-          <a:p>
-            <a:pPr algn="l"/>
-          </a:p>
-          <a:p>
-            <a:pPr algn="l"/>
-            <a:r>
-              <a:rPr sz="1600">
-                <a:latin typeface="Aptos"/>
-              </a:rPr>
-              <a:t>Category: C04 | Region: Unknown</a:t>
-            </a:r>
-          </a:p>
-          <a:p>
-            <a:pPr algn="l"/>
-            <a:r>
-              <a:rPr sz="1600">
-                <a:latin typeface="Aptos"/>
-              </a:rPr>
-              <a:t>Sentiment: -58.2 | EHI: 57.9% | Priority: Unscored</a:t>
+              <a:t>Improve 'Seat belts' for G60 customers.</a:t>
+            </a:r>
+          </a:p>
+          <a:p>
+            <a:pPr algn="l"/>
+          </a:p>
+          <a:p>
+            <a:pPr algn="l"/>
+            <a:r>
+              <a:rPr sz="1600">
+                <a:latin typeface="Aptos"/>
+              </a:rPr>
+              <a:t>Category: C04 | Region: All markets</a:t>
+            </a:r>
+          </a:p>
+          <a:p>
+            <a:pPr algn="l"/>
+            <a:r>
+              <a:rPr sz="1600">
+                <a:latin typeface="Aptos"/>
+              </a:rPr>
+              <a:t>Sentiment: -46.9 | EHI: 73.9% | Priority: Unscored</a:t>
             </a:r>
           </a:p>
           <a:p>
@@ -6931,34 +6967,34 @@
               <a:rPr sz="1600">
                 <a:latin typeface="Aptos"/>
               </a:rPr>
-              <a:t>• bmw-file://G60_feedback_hackathon.xlsx — Feedback_Explorer!row 1030</a:t>
-            </a:r>
-          </a:p>
-          <a:p>
-            <a:pPr algn="l"/>
-            <a:r>
-              <a:rPr sz="1600">
-                <a:latin typeface="Aptos"/>
-              </a:rPr>
-              <a:t>• bmw-file://G60_feedback_hackathon.xlsx — Feedback_Explorer!row 1129</a:t>
-            </a:r>
-          </a:p>
-          <a:p>
-            <a:pPr algn="l"/>
-            <a:r>
-              <a:rPr sz="1600">
-                <a:latin typeface="Aptos"/>
-              </a:rPr>
-              <a:t>• bmw-file://G60_feedback_hackathon.xlsx — Feedback_Explorer!row 1161</a:t>
-            </a:r>
-          </a:p>
-          <a:p>
-            <a:pPr algn="l"/>
-            <a:r>
-              <a:rPr sz="1600">
-                <a:latin typeface="Aptos"/>
-              </a:rPr>
-              <a:t>• bmw-file://G60_feedback_hackathon.xlsx — Feedback_Explorer!row 1189</a:t>
+              <a:t>• bmw-file://G60_feedback_hackathon.xlsx — Feedback_Explorer!row 45</a:t>
+            </a:r>
+          </a:p>
+          <a:p>
+            <a:pPr algn="l"/>
+            <a:r>
+              <a:rPr sz="1600">
+                <a:latin typeface="Aptos"/>
+              </a:rPr>
+              <a:t>• bmw-file://G60_feedback_hackathon.xlsx — Feedback_Explorer!row 284</a:t>
+            </a:r>
+          </a:p>
+          <a:p>
+            <a:pPr algn="l"/>
+            <a:r>
+              <a:rPr sz="1600">
+                <a:latin typeface="Aptos"/>
+              </a:rPr>
+              <a:t>• bmw-file://G60_feedback_hackathon.xlsx — Feedback_Explorer!row 1007</a:t>
+            </a:r>
+          </a:p>
+          <a:p>
+            <a:pPr algn="l"/>
+            <a:r>
+              <a:rPr sz="1600">
+                <a:latin typeface="Aptos"/>
+              </a:rPr>
+              <a:t>• bmw-file://G60_feedback_hackathon.xlsx — Feedback_Explorer!row 1053</a:t>
             </a:r>
           </a:p>
           <a:p>
@@ -7040,7 +7076,7 @@
               <a:rPr sz="1600">
                 <a:latin typeface="Aptos"/>
               </a:rPr>
-              <a:t>Critical review: G70 Sensor</a:t>
+              <a:t>Critical review: G60 Lane departure warning</a:t>
             </a:r>
           </a:p>
         </p:txBody>
@@ -7065,7 +7101,7 @@
               <a:rPr sz="1600">
                 <a:latin typeface="Aptos"/>
               </a:rPr>
-              <a:t>Improve sensor for G70 customers.</a:t>
+              <a:t>Improve 'Lane departure warning' for G60 customers.</a:t>
             </a:r>
           </a:p>
           <a:p>
@@ -7086,7 +7122,7 @@
               <a:rPr sz="1600">
                 <a:latin typeface="Aptos"/>
               </a:rPr>
-              <a:t>Sentiment: -50.8 | EHI: 57.2% | Priority: Unscored</a:t>
+              <a:t>Sentiment: -26.8 | EHI: 73.9% | Priority: Unscored</a:t>
             </a:r>
           </a:p>
           <a:p>
@@ -7107,34 +7143,34 @@
               <a:rPr sz="1600">
                 <a:latin typeface="Aptos"/>
               </a:rPr>
-              <a:t>• bmw-file://G70_feedback_hackathon.xlsx — Feedback_Explorer!row 172</a:t>
-            </a:r>
-          </a:p>
-          <a:p>
-            <a:pPr algn="l"/>
-            <a:r>
-              <a:rPr sz="1600">
-                <a:latin typeface="Aptos"/>
-              </a:rPr>
-              <a:t>• bmw-file://G70_feedback_hackathon.xlsx — Feedback_Explorer!row 408</a:t>
-            </a:r>
-          </a:p>
-          <a:p>
-            <a:pPr algn="l"/>
-            <a:r>
-              <a:rPr sz="1600">
-                <a:latin typeface="Aptos"/>
-              </a:rPr>
-              <a:t>• bmw-file://G70_feedback_hackathon.xlsx — Feedback_Explorer!row 599</a:t>
-            </a:r>
-          </a:p>
-          <a:p>
-            <a:pPr algn="l"/>
-            <a:r>
-              <a:rPr sz="1600">
-                <a:latin typeface="Aptos"/>
-              </a:rPr>
-              <a:t>• bmw-file://G70_feedback_hackathon.xlsx — Feedback_Explorer!row 727</a:t>
+              <a:t>• bmw-file://G60_feedback_hackathon.xlsx — Feedback_Explorer!row 172</a:t>
+            </a:r>
+          </a:p>
+          <a:p>
+            <a:pPr algn="l"/>
+            <a:r>
+              <a:rPr sz="1600">
+                <a:latin typeface="Aptos"/>
+              </a:rPr>
+              <a:t>• bmw-file://G60_feedback_hackathon.xlsx — Feedback_Explorer!row 306</a:t>
+            </a:r>
+          </a:p>
+          <a:p>
+            <a:pPr algn="l"/>
+            <a:r>
+              <a:rPr sz="1600">
+                <a:latin typeface="Aptos"/>
+              </a:rPr>
+              <a:t>• bmw-file://G60_feedback_hackathon.xlsx — Feedback_Explorer!row 906</a:t>
+            </a:r>
+          </a:p>
+          <a:p>
+            <a:pPr algn="l"/>
+            <a:r>
+              <a:rPr sz="1600">
+                <a:latin typeface="Aptos"/>
+              </a:rPr>
+              <a:t>• bmw-file://G60_feedback_hackathon.xlsx — Feedback_Explorer!row 1649</a:t>
             </a:r>
           </a:p>
           <a:p>
@@ -7216,7 +7252,7 @@
               <a:rPr sz="1600">
                 <a:latin typeface="Aptos"/>
               </a:rPr>
-              <a:t>Critical review: G60 Warning</a:t>
+              <a:t>Critical review: G70 Emergency request</a:t>
             </a:r>
           </a:p>
         </p:txBody>
@@ -7241,28 +7277,28 @@
               <a:rPr sz="1600">
                 <a:latin typeface="Aptos"/>
               </a:rPr>
-              <a:t>Improve warning for G60 customers.</a:t>
-            </a:r>
-          </a:p>
-          <a:p>
-            <a:pPr algn="l"/>
-          </a:p>
-          <a:p>
-            <a:pPr algn="l"/>
-            <a:r>
-              <a:rPr sz="1600">
-                <a:latin typeface="Aptos"/>
-              </a:rPr>
-              <a:t>Category: C04 | Region: Unknown</a:t>
-            </a:r>
-          </a:p>
-          <a:p>
-            <a:pPr algn="l"/>
-            <a:r>
-              <a:rPr sz="1600">
-                <a:latin typeface="Aptos"/>
-              </a:rPr>
-              <a:t>Sentiment: -50.0 | EHI: 64.5% | Priority: Unscored</a:t>
+              <a:t>Improve 'Emergency request' for G70 customers.</a:t>
+            </a:r>
+          </a:p>
+          <a:p>
+            <a:pPr algn="l"/>
+          </a:p>
+          <a:p>
+            <a:pPr algn="l"/>
+            <a:r>
+              <a:rPr sz="1600">
+                <a:latin typeface="Aptos"/>
+              </a:rPr>
+              <a:t>Category: C04 | Region: US</a:t>
+            </a:r>
+          </a:p>
+          <a:p>
+            <a:pPr algn="l"/>
+            <a:r>
+              <a:rPr sz="1600">
+                <a:latin typeface="Aptos"/>
+              </a:rPr>
+              <a:t>Sentiment: -76.2 | EHI: 69.3% | Priority: Unscored</a:t>
             </a:r>
           </a:p>
           <a:p>
@@ -7283,34 +7319,34 @@
               <a:rPr sz="1600">
                 <a:latin typeface="Aptos"/>
               </a:rPr>
-              <a:t>• bmw-file://G60_feedback_hackathon.xlsx — Feedback_Explorer!row 25</a:t>
-            </a:r>
-          </a:p>
-          <a:p>
-            <a:pPr algn="l"/>
-            <a:r>
-              <a:rPr sz="1600">
-                <a:latin typeface="Aptos"/>
-              </a:rPr>
-              <a:t>• bmw-file://G60_feedback_hackathon.xlsx — Feedback_Explorer!row 112</a:t>
-            </a:r>
-          </a:p>
-          <a:p>
-            <a:pPr algn="l"/>
-            <a:r>
-              <a:rPr sz="1600">
-                <a:latin typeface="Aptos"/>
-              </a:rPr>
-              <a:t>• bmw-file://G60_feedback_hackathon.xlsx — Feedback_Explorer!row 172</a:t>
-            </a:r>
-          </a:p>
-          <a:p>
-            <a:pPr algn="l"/>
-            <a:r>
-              <a:rPr sz="1600">
-                <a:latin typeface="Aptos"/>
-              </a:rPr>
-              <a:t>• bmw-file://G60_feedback_hackathon.xlsx — Feedback_Explorer!row 218</a:t>
+              <a:t>• bmw-file://G70_feedback_hackathon.xlsx — Feedback_Explorer!row 158</a:t>
+            </a:r>
+          </a:p>
+          <a:p>
+            <a:pPr algn="l"/>
+            <a:r>
+              <a:rPr sz="1600">
+                <a:latin typeface="Aptos"/>
+              </a:rPr>
+              <a:t>• bmw-file://G70_feedback_hackathon.xlsx — Feedback_Explorer!row 3079</a:t>
+            </a:r>
+          </a:p>
+          <a:p>
+            <a:pPr algn="l"/>
+            <a:r>
+              <a:rPr sz="1600">
+                <a:latin typeface="Aptos"/>
+              </a:rPr>
+              <a:t>• bmw-file://G70_feedback_hackathon.xlsx — Feedback_Explorer!row 3104</a:t>
+            </a:r>
+          </a:p>
+          <a:p>
+            <a:pPr algn="l"/>
+            <a:r>
+              <a:rPr sz="1600">
+                <a:latin typeface="Aptos"/>
+              </a:rPr>
+              <a:t>• bmw-file://G70_feedback_hackathon.xlsx — Feedback_Explorer!row 3183</a:t>
             </a:r>
           </a:p>
           <a:p>
@@ -7392,7 +7428,7 @@
               <a:rPr sz="1600">
                 <a:latin typeface="Aptos"/>
               </a:rPr>
-              <a:t>Critical review: G70 Warning</a:t>
+              <a:t>Critical review: G60 Emergency request</a:t>
             </a:r>
           </a:p>
         </p:txBody>
@@ -7417,7 +7453,7 @@
               <a:rPr sz="1600">
                 <a:latin typeface="Aptos"/>
               </a:rPr>
-              <a:t>Improve warning for G70 customers.</a:t>
+              <a:t>Improve 'Emergency request' for G60 customers.</a:t>
             </a:r>
           </a:p>
           <a:p>
@@ -7438,7 +7474,7 @@
               <a:rPr sz="1600">
                 <a:latin typeface="Aptos"/>
               </a:rPr>
-              <a:t>Sentiment: -40.5 | EHI: 67.2% | Priority: Unscored</a:t>
+              <a:t>Sentiment: -53.1 | EHI: 69.3% | Priority: Unscored</a:t>
             </a:r>
           </a:p>
           <a:p>
@@ -7459,34 +7495,34 @@
               <a:rPr sz="1600">
                 <a:latin typeface="Aptos"/>
               </a:rPr>
-              <a:t>• bmw-file://G70_feedback_hackathon.xlsx — Feedback_Explorer!row 65</a:t>
-            </a:r>
-          </a:p>
-          <a:p>
-            <a:pPr algn="l"/>
-            <a:r>
-              <a:rPr sz="1600">
-                <a:latin typeface="Aptos"/>
-              </a:rPr>
-              <a:t>• bmw-file://G70_feedback_hackathon.xlsx — Feedback_Explorer!row 98</a:t>
-            </a:r>
-          </a:p>
-          <a:p>
-            <a:pPr algn="l"/>
-            <a:r>
-              <a:rPr sz="1600">
-                <a:latin typeface="Aptos"/>
-              </a:rPr>
-              <a:t>• bmw-file://G70_feedback_hackathon.xlsx — Feedback_Explorer!row 151</a:t>
-            </a:r>
-          </a:p>
-          <a:p>
-            <a:pPr algn="l"/>
-            <a:r>
-              <a:rPr sz="1600">
-                <a:latin typeface="Aptos"/>
-              </a:rPr>
-              <a:t>• bmw-file://G70_feedback_hackathon.xlsx — Feedback_Explorer!row 172</a:t>
+              <a:t>• bmw-file://G60_feedback_hackathon.xlsx — Feedback_Explorer!row 1161</a:t>
+            </a:r>
+          </a:p>
+          <a:p>
+            <a:pPr algn="l"/>
+            <a:r>
+              <a:rPr sz="1600">
+                <a:latin typeface="Aptos"/>
+              </a:rPr>
+              <a:t>• bmw-file://G60_feedback_hackathon.xlsx — Feedback_Explorer!row 1189</a:t>
+            </a:r>
+          </a:p>
+          <a:p>
+            <a:pPr algn="l"/>
+            <a:r>
+              <a:rPr sz="1600">
+                <a:latin typeface="Aptos"/>
+              </a:rPr>
+              <a:t>• bmw-file://G60_feedback_hackathon.xlsx — Feedback_Explorer!row 1910</a:t>
+            </a:r>
+          </a:p>
+          <a:p>
+            <a:pPr algn="l"/>
+            <a:r>
+              <a:rPr sz="1600">
+                <a:latin typeface="Aptos"/>
+              </a:rPr>
+              <a:t>• bmw-file://G60_feedback_hackathon.xlsx — Feedback_Explorer!row 2267</a:t>
             </a:r>
           </a:p>
           <a:p>

</xml_diff>